<commit_message>
ajustes na apresentação e validação do modelo
</commit_message>
<xml_diff>
--- a/presentation/ifood_case_presentation_AnaClaraFernandes.pptx
+++ b/presentation/ifood_case_presentation_AnaClaraFernandes.pptx
@@ -5,7 +5,7 @@
     <p:sldMasterId id="2147483648" r:id="rId1"/>
   </p:sldMasterIdLst>
   <p:notesMasterIdLst>
-    <p:notesMasterId r:id="rId7"/>
+    <p:notesMasterId r:id="rId9"/>
   </p:notesMasterIdLst>
   <p:sldIdLst>
     <p:sldId id="256" r:id="rId2"/>
@@ -13,6 +13,8 @@
     <p:sldId id="258" r:id="rId4"/>
     <p:sldId id="259" r:id="rId5"/>
     <p:sldId id="260" r:id="rId6"/>
+    <p:sldId id="262" r:id="rId7"/>
+    <p:sldId id="263" r:id="rId8"/>
   </p:sldIdLst>
   <p:sldSz cx="9144000" cy="5143500" type="screen16x9"/>
   <p:notesSz cx="5143500" cy="9144000"/>
@@ -109,11 +111,524 @@
     </a:lvl9pPr>
   </p:defaultTextStyle>
   <p:extLst>
+    <p:ext uri="{521415D9-36F7-43E2-AB2F-B90AF26B5E84}">
+      <p14:sectionLst xmlns:p14="http://schemas.microsoft.com/office/powerpoint/2010/main">
+        <p14:section name="Seção Padrão" id="{1BDBBF33-43BC-4874-B905-0A189F174BB3}">
+          <p14:sldIdLst>
+            <p14:sldId id="256"/>
+            <p14:sldId id="257"/>
+            <p14:sldId id="258"/>
+            <p14:sldId id="259"/>
+            <p14:sldId id="260"/>
+          </p14:sldIdLst>
+        </p14:section>
+        <p14:section name="backup" id="{B0A74462-E71D-44AF-A95D-26A5965FCF55}">
+          <p14:sldIdLst>
+            <p14:sldId id="262"/>
+            <p14:sldId id="263"/>
+          </p14:sldIdLst>
+        </p14:section>
+      </p14:sectionLst>
+    </p:ext>
     <p:ext uri="{EFAFB233-063F-42B5-8137-9DF3F51BA10A}">
       <p15:sldGuideLst xmlns:p15="http://schemas.microsoft.com/office/powerpoint/2012/main"/>
     </p:ext>
   </p:extLst>
 </p:presentation>
+</file>
+
+<file path=ppt/revisionInfo.xml><?xml version="1.0" encoding="utf-8"?>
+<p1510:revInfo xmlns:a="http://schemas.openxmlformats.org/drawingml/2006/main" xmlns:r="http://schemas.openxmlformats.org/officeDocument/2006/relationships" xmlns:p1510="http://schemas.microsoft.com/office/powerpoint/2015/10/main">
+  <p1510:revLst>
+    <p1510:client id="{BF68BEC7-921D-49E6-ADB3-E5201666F6E7}" v="7" dt="2026-07-01T21:48:07.853"/>
+  </p1510:revLst>
+</p1510:revInfo>
+</file>
+
+<file path=ppt/changesInfos/changesInfo1.xml><?xml version="1.0" encoding="utf-8"?>
+<pc:chgInfo xmlns:a="http://schemas.openxmlformats.org/drawingml/2006/main" xmlns:r="http://schemas.openxmlformats.org/officeDocument/2006/relationships" xmlns:ac="http://schemas.microsoft.com/office/drawing/2013/main/command" xmlns:pc="http://schemas.microsoft.com/office/powerpoint/2013/main/command">
+  <pc:docChgLst>
+    <pc:chgData name="Ana Clara Fernandes" userId="663cf3de9617d588" providerId="LiveId" clId="{3B27595F-788B-43A8-BC19-B0A17F7CB2BD}"/>
+    <pc:docChg chg="undo custSel addSld delSld modSld sldOrd addSection modSection">
+      <pc:chgData name="Ana Clara Fernandes" userId="663cf3de9617d588" providerId="LiveId" clId="{3B27595F-788B-43A8-BC19-B0A17F7CB2BD}" dt="2026-07-01T21:52:56.715" v="1057" actId="20577"/>
+      <pc:docMkLst>
+        <pc:docMk/>
+      </pc:docMkLst>
+      <pc:sldChg chg="delSp modSp mod">
+        <pc:chgData name="Ana Clara Fernandes" userId="663cf3de9617d588" providerId="LiveId" clId="{3B27595F-788B-43A8-BC19-B0A17F7CB2BD}" dt="2026-07-01T21:47:25.045" v="811" actId="478"/>
+        <pc:sldMkLst>
+          <pc:docMk/>
+          <pc:sldMk cId="0" sldId="256"/>
+        </pc:sldMkLst>
+        <pc:spChg chg="del">
+          <ac:chgData name="Ana Clara Fernandes" userId="663cf3de9617d588" providerId="LiveId" clId="{3B27595F-788B-43A8-BC19-B0A17F7CB2BD}" dt="2026-07-01T21:47:25.045" v="811" actId="478"/>
+          <ac:spMkLst>
+            <pc:docMk/>
+            <pc:sldMk cId="0" sldId="256"/>
+            <ac:spMk id="17" creationId="{00000000-0000-0000-0000-000000000000}"/>
+          </ac:spMkLst>
+        </pc:spChg>
+        <pc:spChg chg="mod">
+          <ac:chgData name="Ana Clara Fernandes" userId="663cf3de9617d588" providerId="LiveId" clId="{3B27595F-788B-43A8-BC19-B0A17F7CB2BD}" dt="2026-07-01T21:47:19.725" v="810" actId="20577"/>
+          <ac:spMkLst>
+            <pc:docMk/>
+            <pc:sldMk cId="0" sldId="256"/>
+            <ac:spMk id="18" creationId="{941D3B60-72F8-73BF-5A43-4E13893C1A48}"/>
+          </ac:spMkLst>
+        </pc:spChg>
+      </pc:sldChg>
+      <pc:sldChg chg="addSp modSp mod">
+        <pc:chgData name="Ana Clara Fernandes" userId="663cf3de9617d588" providerId="LiveId" clId="{3B27595F-788B-43A8-BC19-B0A17F7CB2BD}" dt="2026-07-01T21:51:56.661" v="1051" actId="6549"/>
+        <pc:sldMkLst>
+          <pc:docMk/>
+          <pc:sldMk cId="0" sldId="257"/>
+        </pc:sldMkLst>
+        <pc:spChg chg="mod">
+          <ac:chgData name="Ana Clara Fernandes" userId="663cf3de9617d588" providerId="LiveId" clId="{3B27595F-788B-43A8-BC19-B0A17F7CB2BD}" dt="2026-07-01T21:47:42.123" v="812" actId="14100"/>
+          <ac:spMkLst>
+            <pc:docMk/>
+            <pc:sldMk cId="0" sldId="257"/>
+            <ac:spMk id="5" creationId="{00000000-0000-0000-0000-000000000000}"/>
+          </ac:spMkLst>
+        </pc:spChg>
+        <pc:spChg chg="mod">
+          <ac:chgData name="Ana Clara Fernandes" userId="663cf3de9617d588" providerId="LiveId" clId="{3B27595F-788B-43A8-BC19-B0A17F7CB2BD}" dt="2026-07-01T21:50:07.851" v="1050" actId="20577"/>
+          <ac:spMkLst>
+            <pc:docMk/>
+            <pc:sldMk cId="0" sldId="257"/>
+            <ac:spMk id="15" creationId="{00000000-0000-0000-0000-000000000000}"/>
+          </ac:spMkLst>
+        </pc:spChg>
+        <pc:spChg chg="mod">
+          <ac:chgData name="Ana Clara Fernandes" userId="663cf3de9617d588" providerId="LiveId" clId="{3B27595F-788B-43A8-BC19-B0A17F7CB2BD}" dt="2026-07-01T21:51:56.661" v="1051" actId="6549"/>
+          <ac:spMkLst>
+            <pc:docMk/>
+            <pc:sldMk cId="0" sldId="257"/>
+            <ac:spMk id="17" creationId="{00000000-0000-0000-0000-000000000000}"/>
+          </ac:spMkLst>
+        </pc:spChg>
+        <pc:spChg chg="add mod">
+          <ac:chgData name="Ana Clara Fernandes" userId="663cf3de9617d588" providerId="LiveId" clId="{3B27595F-788B-43A8-BC19-B0A17F7CB2BD}" dt="2026-07-01T21:48:03.283" v="848" actId="20577"/>
+          <ac:spMkLst>
+            <pc:docMk/>
+            <pc:sldMk cId="0" sldId="257"/>
+            <ac:spMk id="18" creationId="{7B870B82-C49A-5DA1-26DE-4C4758895C56}"/>
+          </ac:spMkLst>
+        </pc:spChg>
+        <pc:spChg chg="add mod">
+          <ac:chgData name="Ana Clara Fernandes" userId="663cf3de9617d588" providerId="LiveId" clId="{3B27595F-788B-43A8-BC19-B0A17F7CB2BD}" dt="2026-07-01T21:49:57.840" v="1027" actId="1076"/>
+          <ac:spMkLst>
+            <pc:docMk/>
+            <pc:sldMk cId="0" sldId="257"/>
+            <ac:spMk id="19" creationId="{307EF5C3-2FAB-9FCC-DE4F-4733EB3157E2}"/>
+          </ac:spMkLst>
+        </pc:spChg>
+      </pc:sldChg>
+      <pc:sldChg chg="addSp delSp modSp mod">
+        <pc:chgData name="Ana Clara Fernandes" userId="663cf3de9617d588" providerId="LiveId" clId="{3B27595F-788B-43A8-BC19-B0A17F7CB2BD}" dt="2026-07-01T21:35:28.107" v="571" actId="1076"/>
+        <pc:sldMkLst>
+          <pc:docMk/>
+          <pc:sldMk cId="0" sldId="258"/>
+        </pc:sldMkLst>
+        <pc:spChg chg="add del">
+          <ac:chgData name="Ana Clara Fernandes" userId="663cf3de9617d588" providerId="LiveId" clId="{3B27595F-788B-43A8-BC19-B0A17F7CB2BD}" dt="2026-07-01T21:35:19.637" v="568" actId="478"/>
+          <ac:spMkLst>
+            <pc:docMk/>
+            <pc:sldMk cId="0" sldId="258"/>
+            <ac:spMk id="17" creationId="{00000000-0000-0000-0000-000000000000}"/>
+          </ac:spMkLst>
+        </pc:spChg>
+        <pc:spChg chg="mod">
+          <ac:chgData name="Ana Clara Fernandes" userId="663cf3de9617d588" providerId="LiveId" clId="{3B27595F-788B-43A8-BC19-B0A17F7CB2BD}" dt="2026-07-01T21:35:24.058" v="569" actId="6549"/>
+          <ac:spMkLst>
+            <pc:docMk/>
+            <pc:sldMk cId="0" sldId="258"/>
+            <ac:spMk id="18" creationId="{00000000-0000-0000-0000-000000000000}"/>
+          </ac:spMkLst>
+        </pc:spChg>
+        <pc:spChg chg="add mod">
+          <ac:chgData name="Ana Clara Fernandes" userId="663cf3de9617d588" providerId="LiveId" clId="{3B27595F-788B-43A8-BC19-B0A17F7CB2BD}" dt="2026-07-01T21:35:28.107" v="571" actId="1076"/>
+          <ac:spMkLst>
+            <pc:docMk/>
+            <pc:sldMk cId="0" sldId="258"/>
+            <ac:spMk id="19" creationId="{366F5EDB-91A4-E90E-2B0D-6A99F579F657}"/>
+          </ac:spMkLst>
+        </pc:spChg>
+      </pc:sldChg>
+      <pc:sldChg chg="addSp modSp mod">
+        <pc:chgData name="Ana Clara Fernandes" userId="663cf3de9617d588" providerId="LiveId" clId="{3B27595F-788B-43A8-BC19-B0A17F7CB2BD}" dt="2026-07-01T21:43:46.840" v="653" actId="1076"/>
+        <pc:sldMkLst>
+          <pc:docMk/>
+          <pc:sldMk cId="0" sldId="259"/>
+        </pc:sldMkLst>
+        <pc:spChg chg="mod">
+          <ac:chgData name="Ana Clara Fernandes" userId="663cf3de9617d588" providerId="LiveId" clId="{3B27595F-788B-43A8-BC19-B0A17F7CB2BD}" dt="2026-07-01T21:23:58.480" v="257" actId="20577"/>
+          <ac:spMkLst>
+            <pc:docMk/>
+            <pc:sldMk cId="0" sldId="259"/>
+            <ac:spMk id="22" creationId="{00000000-0000-0000-0000-000000000000}"/>
+          </ac:spMkLst>
+        </pc:spChg>
+        <pc:spChg chg="add mod">
+          <ac:chgData name="Ana Clara Fernandes" userId="663cf3de9617d588" providerId="LiveId" clId="{3B27595F-788B-43A8-BC19-B0A17F7CB2BD}" dt="2026-07-01T21:43:46.840" v="653" actId="1076"/>
+          <ac:spMkLst>
+            <pc:docMk/>
+            <pc:sldMk cId="0" sldId="259"/>
+            <ac:spMk id="24" creationId="{3A607922-F542-804B-A109-A340348E6E02}"/>
+          </ac:spMkLst>
+        </pc:spChg>
+      </pc:sldChg>
+      <pc:sldChg chg="modSp mod">
+        <pc:chgData name="Ana Clara Fernandes" userId="663cf3de9617d588" providerId="LiveId" clId="{3B27595F-788B-43A8-BC19-B0A17F7CB2BD}" dt="2026-07-01T21:52:56.715" v="1057" actId="20577"/>
+        <pc:sldMkLst>
+          <pc:docMk/>
+          <pc:sldMk cId="0" sldId="260"/>
+        </pc:sldMkLst>
+        <pc:spChg chg="mod">
+          <ac:chgData name="Ana Clara Fernandes" userId="663cf3de9617d588" providerId="LiveId" clId="{3B27595F-788B-43A8-BC19-B0A17F7CB2BD}" dt="2026-07-01T21:45:50.264" v="781" actId="20577"/>
+          <ac:spMkLst>
+            <pc:docMk/>
+            <pc:sldMk cId="0" sldId="260"/>
+            <ac:spMk id="7" creationId="{00000000-0000-0000-0000-000000000000}"/>
+          </ac:spMkLst>
+        </pc:spChg>
+        <pc:spChg chg="mod">
+          <ac:chgData name="Ana Clara Fernandes" userId="663cf3de9617d588" providerId="LiveId" clId="{3B27595F-788B-43A8-BC19-B0A17F7CB2BD}" dt="2026-07-01T21:26:31.721" v="323" actId="20577"/>
+          <ac:spMkLst>
+            <pc:docMk/>
+            <pc:sldMk cId="0" sldId="260"/>
+            <ac:spMk id="10" creationId="{00000000-0000-0000-0000-000000000000}"/>
+          </ac:spMkLst>
+        </pc:spChg>
+        <pc:spChg chg="mod">
+          <ac:chgData name="Ana Clara Fernandes" userId="663cf3de9617d588" providerId="LiveId" clId="{3B27595F-788B-43A8-BC19-B0A17F7CB2BD}" dt="2026-07-01T20:45:03.688" v="1" actId="1076"/>
+          <ac:spMkLst>
+            <pc:docMk/>
+            <pc:sldMk cId="0" sldId="260"/>
+            <ac:spMk id="16" creationId="{00000000-0000-0000-0000-000000000000}"/>
+          </ac:spMkLst>
+        </pc:spChg>
+        <pc:spChg chg="mod">
+          <ac:chgData name="Ana Clara Fernandes" userId="663cf3de9617d588" providerId="LiveId" clId="{3B27595F-788B-43A8-BC19-B0A17F7CB2BD}" dt="2026-07-01T21:45:21.055" v="766" actId="20577"/>
+          <ac:spMkLst>
+            <pc:docMk/>
+            <pc:sldMk cId="0" sldId="260"/>
+            <ac:spMk id="18" creationId="{00000000-0000-0000-0000-000000000000}"/>
+          </ac:spMkLst>
+        </pc:spChg>
+        <pc:spChg chg="mod">
+          <ac:chgData name="Ana Clara Fernandes" userId="663cf3de9617d588" providerId="LiveId" clId="{3B27595F-788B-43A8-BC19-B0A17F7CB2BD}" dt="2026-07-01T21:52:56.715" v="1057" actId="20577"/>
+          <ac:spMkLst>
+            <pc:docMk/>
+            <pc:sldMk cId="0" sldId="260"/>
+            <ac:spMk id="24" creationId="{00000000-0000-0000-0000-000000000000}"/>
+          </ac:spMkLst>
+        </pc:spChg>
+        <pc:spChg chg="mod">
+          <ac:chgData name="Ana Clara Fernandes" userId="663cf3de9617d588" providerId="LiveId" clId="{3B27595F-788B-43A8-BC19-B0A17F7CB2BD}" dt="2026-07-01T21:25:04.484" v="260" actId="6549"/>
+          <ac:spMkLst>
+            <pc:docMk/>
+            <pc:sldMk cId="0" sldId="260"/>
+            <ac:spMk id="26" creationId="{00000000-0000-0000-0000-000000000000}"/>
+          </ac:spMkLst>
+        </pc:spChg>
+      </pc:sldChg>
+      <pc:sldChg chg="new del">
+        <pc:chgData name="Ana Clara Fernandes" userId="663cf3de9617d588" providerId="LiveId" clId="{3B27595F-788B-43A8-BC19-B0A17F7CB2BD}" dt="2026-07-01T21:01:47.210" v="8" actId="47"/>
+        <pc:sldMkLst>
+          <pc:docMk/>
+          <pc:sldMk cId="2205731706" sldId="261"/>
+        </pc:sldMkLst>
+      </pc:sldChg>
+      <pc:sldChg chg="addSp delSp modSp add mod ord modNotesTx">
+        <pc:chgData name="Ana Clara Fernandes" userId="663cf3de9617d588" providerId="LiveId" clId="{3B27595F-788B-43A8-BC19-B0A17F7CB2BD}" dt="2026-07-01T21:46:59.241" v="808" actId="20577"/>
+        <pc:sldMkLst>
+          <pc:docMk/>
+          <pc:sldMk cId="3401654431" sldId="262"/>
+        </pc:sldMkLst>
+        <pc:spChg chg="mod">
+          <ac:chgData name="Ana Clara Fernandes" userId="663cf3de9617d588" providerId="LiveId" clId="{3B27595F-788B-43A8-BC19-B0A17F7CB2BD}" dt="2026-07-01T21:02:01.508" v="27" actId="20577"/>
+          <ac:spMkLst>
+            <pc:docMk/>
+            <pc:sldMk cId="3401654431" sldId="262"/>
+            <ac:spMk id="3" creationId="{36C7E697-EAC8-D19D-9947-5661D8A7D72E}"/>
+          </ac:spMkLst>
+        </pc:spChg>
+        <pc:spChg chg="del">
+          <ac:chgData name="Ana Clara Fernandes" userId="663cf3de9617d588" providerId="LiveId" clId="{3B27595F-788B-43A8-BC19-B0A17F7CB2BD}" dt="2026-07-01T21:06:33.601" v="29" actId="478"/>
+          <ac:spMkLst>
+            <pc:docMk/>
+            <pc:sldMk cId="3401654431" sldId="262"/>
+            <ac:spMk id="4" creationId="{97A29758-6318-6007-986D-53D1625C15F6}"/>
+          </ac:spMkLst>
+        </pc:spChg>
+        <pc:spChg chg="del">
+          <ac:chgData name="Ana Clara Fernandes" userId="663cf3de9617d588" providerId="LiveId" clId="{3B27595F-788B-43A8-BC19-B0A17F7CB2BD}" dt="2026-07-01T21:07:08.247" v="44" actId="478"/>
+          <ac:spMkLst>
+            <pc:docMk/>
+            <pc:sldMk cId="3401654431" sldId="262"/>
+            <ac:spMk id="5" creationId="{2A794486-C681-3D41-F6BB-ECDB4B0A225A}"/>
+          </ac:spMkLst>
+        </pc:spChg>
+        <pc:spChg chg="add del mod">
+          <ac:chgData name="Ana Clara Fernandes" userId="663cf3de9617d588" providerId="LiveId" clId="{3B27595F-788B-43A8-BC19-B0A17F7CB2BD}" dt="2026-07-01T21:07:08.247" v="44" actId="478"/>
+          <ac:spMkLst>
+            <pc:docMk/>
+            <pc:sldMk cId="3401654431" sldId="262"/>
+            <ac:spMk id="6" creationId="{DE9A7642-8A91-D6F1-296C-67B8AE5DFCAD}"/>
+          </ac:spMkLst>
+        </pc:spChg>
+        <pc:spChg chg="del">
+          <ac:chgData name="Ana Clara Fernandes" userId="663cf3de9617d588" providerId="LiveId" clId="{3B27595F-788B-43A8-BC19-B0A17F7CB2BD}" dt="2026-07-01T21:07:08.247" v="44" actId="478"/>
+          <ac:spMkLst>
+            <pc:docMk/>
+            <pc:sldMk cId="3401654431" sldId="262"/>
+            <ac:spMk id="7" creationId="{074B8B5C-E817-9A43-445A-5668DED8A633}"/>
+          </ac:spMkLst>
+        </pc:spChg>
+        <pc:spChg chg="del">
+          <ac:chgData name="Ana Clara Fernandes" userId="663cf3de9617d588" providerId="LiveId" clId="{3B27595F-788B-43A8-BC19-B0A17F7CB2BD}" dt="2026-07-01T21:07:08.247" v="44" actId="478"/>
+          <ac:spMkLst>
+            <pc:docMk/>
+            <pc:sldMk cId="3401654431" sldId="262"/>
+            <ac:spMk id="8" creationId="{5D63F8DB-2D78-FC73-D1D8-354815E31CE2}"/>
+          </ac:spMkLst>
+        </pc:spChg>
+        <pc:spChg chg="del">
+          <ac:chgData name="Ana Clara Fernandes" userId="663cf3de9617d588" providerId="LiveId" clId="{3B27595F-788B-43A8-BC19-B0A17F7CB2BD}" dt="2026-07-01T21:07:08.247" v="44" actId="478"/>
+          <ac:spMkLst>
+            <pc:docMk/>
+            <pc:sldMk cId="3401654431" sldId="262"/>
+            <ac:spMk id="9" creationId="{5D9DC4BC-90C0-DC68-DF8A-9302CDC8D65E}"/>
+          </ac:spMkLst>
+        </pc:spChg>
+        <pc:spChg chg="del">
+          <ac:chgData name="Ana Clara Fernandes" userId="663cf3de9617d588" providerId="LiveId" clId="{3B27595F-788B-43A8-BC19-B0A17F7CB2BD}" dt="2026-07-01T21:07:08.247" v="44" actId="478"/>
+          <ac:spMkLst>
+            <pc:docMk/>
+            <pc:sldMk cId="3401654431" sldId="262"/>
+            <ac:spMk id="10" creationId="{62F98836-6CBD-207F-E616-FF2E4699EB01}"/>
+          </ac:spMkLst>
+        </pc:spChg>
+        <pc:spChg chg="del">
+          <ac:chgData name="Ana Clara Fernandes" userId="663cf3de9617d588" providerId="LiveId" clId="{3B27595F-788B-43A8-BC19-B0A17F7CB2BD}" dt="2026-07-01T21:07:08.247" v="44" actId="478"/>
+          <ac:spMkLst>
+            <pc:docMk/>
+            <pc:sldMk cId="3401654431" sldId="262"/>
+            <ac:spMk id="11" creationId="{8F72379C-5981-8300-2434-3AE5A5D6E25A}"/>
+          </ac:spMkLst>
+        </pc:spChg>
+        <pc:spChg chg="del">
+          <ac:chgData name="Ana Clara Fernandes" userId="663cf3de9617d588" providerId="LiveId" clId="{3B27595F-788B-43A8-BC19-B0A17F7CB2BD}" dt="2026-07-01T21:07:08.247" v="44" actId="478"/>
+          <ac:spMkLst>
+            <pc:docMk/>
+            <pc:sldMk cId="3401654431" sldId="262"/>
+            <ac:spMk id="12" creationId="{09B4B51E-B33E-EFBB-5CB8-AB476186AA9F}"/>
+          </ac:spMkLst>
+        </pc:spChg>
+        <pc:spChg chg="del">
+          <ac:chgData name="Ana Clara Fernandes" userId="663cf3de9617d588" providerId="LiveId" clId="{3B27595F-788B-43A8-BC19-B0A17F7CB2BD}" dt="2026-07-01T21:07:08.247" v="44" actId="478"/>
+          <ac:spMkLst>
+            <pc:docMk/>
+            <pc:sldMk cId="3401654431" sldId="262"/>
+            <ac:spMk id="13" creationId="{573B5518-07C4-E594-6B6B-CF13007227FC}"/>
+          </ac:spMkLst>
+        </pc:spChg>
+        <pc:spChg chg="del">
+          <ac:chgData name="Ana Clara Fernandes" userId="663cf3de9617d588" providerId="LiveId" clId="{3B27595F-788B-43A8-BC19-B0A17F7CB2BD}" dt="2026-07-01T21:06:54.717" v="38" actId="478"/>
+          <ac:spMkLst>
+            <pc:docMk/>
+            <pc:sldMk cId="3401654431" sldId="262"/>
+            <ac:spMk id="14" creationId="{6E87F176-D11E-5C46-CC77-468C86158C18}"/>
+          </ac:spMkLst>
+        </pc:spChg>
+        <pc:spChg chg="del">
+          <ac:chgData name="Ana Clara Fernandes" userId="663cf3de9617d588" providerId="LiveId" clId="{3B27595F-788B-43A8-BC19-B0A17F7CB2BD}" dt="2026-07-01T21:07:10.519" v="45" actId="478"/>
+          <ac:spMkLst>
+            <pc:docMk/>
+            <pc:sldMk cId="3401654431" sldId="262"/>
+            <ac:spMk id="16" creationId="{7E188206-E574-7693-92CF-BEEA490DCD24}"/>
+          </ac:spMkLst>
+        </pc:spChg>
+        <pc:spChg chg="del">
+          <ac:chgData name="Ana Clara Fernandes" userId="663cf3de9617d588" providerId="LiveId" clId="{3B27595F-788B-43A8-BC19-B0A17F7CB2BD}" dt="2026-07-01T21:06:43.600" v="34" actId="478"/>
+          <ac:spMkLst>
+            <pc:docMk/>
+            <pc:sldMk cId="3401654431" sldId="262"/>
+            <ac:spMk id="17" creationId="{745D9CB4-8CD3-B6D6-5B55-7108DB5F0CF6}"/>
+          </ac:spMkLst>
+        </pc:spChg>
+        <pc:spChg chg="del">
+          <ac:chgData name="Ana Clara Fernandes" userId="663cf3de9617d588" providerId="LiveId" clId="{3B27595F-788B-43A8-BC19-B0A17F7CB2BD}" dt="2026-07-01T21:06:46.944" v="35" actId="478"/>
+          <ac:spMkLst>
+            <pc:docMk/>
+            <pc:sldMk cId="3401654431" sldId="262"/>
+            <ac:spMk id="19" creationId="{0173DEFE-1A61-A4CC-2D84-7DFEB2B891AD}"/>
+          </ac:spMkLst>
+        </pc:spChg>
+        <pc:spChg chg="del">
+          <ac:chgData name="Ana Clara Fernandes" userId="663cf3de9617d588" providerId="LiveId" clId="{3B27595F-788B-43A8-BC19-B0A17F7CB2BD}" dt="2026-07-01T21:06:48.820" v="36" actId="478"/>
+          <ac:spMkLst>
+            <pc:docMk/>
+            <pc:sldMk cId="3401654431" sldId="262"/>
+            <ac:spMk id="20" creationId="{E54586A5-090F-B149-8790-4CBC0ED5F0F2}"/>
+          </ac:spMkLst>
+        </pc:spChg>
+        <pc:spChg chg="del">
+          <ac:chgData name="Ana Clara Fernandes" userId="663cf3de9617d588" providerId="LiveId" clId="{3B27595F-788B-43A8-BC19-B0A17F7CB2BD}" dt="2026-07-01T21:06:52.411" v="37" actId="478"/>
+          <ac:spMkLst>
+            <pc:docMk/>
+            <pc:sldMk cId="3401654431" sldId="262"/>
+            <ac:spMk id="21" creationId="{DBAF43AC-E9E8-0265-393B-F60467D76BB8}"/>
+          </ac:spMkLst>
+        </pc:spChg>
+        <pc:spChg chg="del">
+          <ac:chgData name="Ana Clara Fernandes" userId="663cf3de9617d588" providerId="LiveId" clId="{3B27595F-788B-43A8-BC19-B0A17F7CB2BD}" dt="2026-07-01T21:07:26.394" v="49" actId="478"/>
+          <ac:spMkLst>
+            <pc:docMk/>
+            <pc:sldMk cId="3401654431" sldId="262"/>
+            <ac:spMk id="22" creationId="{C253D079-14D8-1A36-7928-03B8BAD9F2B2}"/>
+          </ac:spMkLst>
+        </pc:spChg>
+        <pc:spChg chg="add mod">
+          <ac:chgData name="Ana Clara Fernandes" userId="663cf3de9617d588" providerId="LiveId" clId="{3B27595F-788B-43A8-BC19-B0A17F7CB2BD}" dt="2026-07-01T21:46:59.241" v="808" actId="20577"/>
+          <ac:spMkLst>
+            <pc:docMk/>
+            <pc:sldMk cId="3401654431" sldId="262"/>
+            <ac:spMk id="26" creationId="{12DD0C76-7C84-2279-F58F-9FF85B139B2F}"/>
+          </ac:spMkLst>
+        </pc:spChg>
+        <pc:spChg chg="add mod ord">
+          <ac:chgData name="Ana Clara Fernandes" userId="663cf3de9617d588" providerId="LiveId" clId="{3B27595F-788B-43A8-BC19-B0A17F7CB2BD}" dt="2026-07-01T21:36:25.012" v="577" actId="1076"/>
+          <ac:spMkLst>
+            <pc:docMk/>
+            <pc:sldMk cId="3401654431" sldId="262"/>
+            <ac:spMk id="27" creationId="{BCD4DA31-AB7C-CDE1-B60E-05CA08186176}"/>
+          </ac:spMkLst>
+        </pc:spChg>
+        <pc:spChg chg="add del mod">
+          <ac:chgData name="Ana Clara Fernandes" userId="663cf3de9617d588" providerId="LiveId" clId="{3B27595F-788B-43A8-BC19-B0A17F7CB2BD}" dt="2026-07-01T21:14:13.290" v="256" actId="478"/>
+          <ac:spMkLst>
+            <pc:docMk/>
+            <pc:sldMk cId="3401654431" sldId="262"/>
+            <ac:spMk id="28" creationId="{200A66EB-A67C-68A9-C636-BD635B000EB2}"/>
+          </ac:spMkLst>
+        </pc:spChg>
+        <pc:spChg chg="add del mod">
+          <ac:chgData name="Ana Clara Fernandes" userId="663cf3de9617d588" providerId="LiveId" clId="{3B27595F-788B-43A8-BC19-B0A17F7CB2BD}" dt="2026-07-01T21:28:58.482" v="442" actId="478"/>
+          <ac:spMkLst>
+            <pc:docMk/>
+            <pc:sldMk cId="3401654431" sldId="262"/>
+            <ac:spMk id="29" creationId="{B4738A5F-493A-CCD6-E852-6CC67418BAB9}"/>
+          </ac:spMkLst>
+        </pc:spChg>
+        <pc:spChg chg="add mod ord">
+          <ac:chgData name="Ana Clara Fernandes" userId="663cf3de9617d588" providerId="LiveId" clId="{3B27595F-788B-43A8-BC19-B0A17F7CB2BD}" dt="2026-07-01T21:36:10.476" v="575" actId="167"/>
+          <ac:spMkLst>
+            <pc:docMk/>
+            <pc:sldMk cId="3401654431" sldId="262"/>
+            <ac:spMk id="32" creationId="{43796242-EF2D-F92D-EB49-3BA23A697CB3}"/>
+          </ac:spMkLst>
+        </pc:spChg>
+        <pc:graphicFrameChg chg="del">
+          <ac:chgData name="Ana Clara Fernandes" userId="663cf3de9617d588" providerId="LiveId" clId="{3B27595F-788B-43A8-BC19-B0A17F7CB2BD}" dt="2026-07-01T21:06:56.904" v="39" actId="478"/>
+          <ac:graphicFrameMkLst>
+            <pc:docMk/>
+            <pc:sldMk cId="3401654431" sldId="262"/>
+            <ac:graphicFrameMk id="15" creationId="{3D5CE9EC-8AB7-579E-A6A1-DF82E672BBB7}"/>
+          </ac:graphicFrameMkLst>
+        </pc:graphicFrameChg>
+        <pc:graphicFrameChg chg="del">
+          <ac:chgData name="Ana Clara Fernandes" userId="663cf3de9617d588" providerId="LiveId" clId="{3B27595F-788B-43A8-BC19-B0A17F7CB2BD}" dt="2026-07-01T21:06:41.992" v="33" actId="478"/>
+          <ac:graphicFrameMkLst>
+            <pc:docMk/>
+            <pc:sldMk cId="3401654431" sldId="262"/>
+            <ac:graphicFrameMk id="18" creationId="{18A95064-1411-5A55-1EC7-5069F994C4D3}"/>
+          </ac:graphicFrameMkLst>
+        </pc:graphicFrameChg>
+        <pc:picChg chg="add del mod">
+          <ac:chgData name="Ana Clara Fernandes" userId="663cf3de9617d588" providerId="LiveId" clId="{3B27595F-788B-43A8-BC19-B0A17F7CB2BD}" dt="2026-07-01T21:28:57.319" v="441" actId="478"/>
+          <ac:picMkLst>
+            <pc:docMk/>
+            <pc:sldMk cId="3401654431" sldId="262"/>
+            <ac:picMk id="24" creationId="{AD78892E-2FD2-C5A3-C0CC-F24AD645670D}"/>
+          </ac:picMkLst>
+        </pc:picChg>
+        <pc:picChg chg="add mod">
+          <ac:chgData name="Ana Clara Fernandes" userId="663cf3de9617d588" providerId="LiveId" clId="{3B27595F-788B-43A8-BC19-B0A17F7CB2BD}" dt="2026-07-01T21:46:27.142" v="782" actId="14100"/>
+          <ac:picMkLst>
+            <pc:docMk/>
+            <pc:sldMk cId="3401654431" sldId="262"/>
+            <ac:picMk id="31" creationId="{B458D7F8-DBB0-2E7B-22CC-C0B3EB70B881}"/>
+          </ac:picMkLst>
+        </pc:picChg>
+      </pc:sldChg>
+      <pc:sldChg chg="addSp delSp modSp add mod">
+        <pc:chgData name="Ana Clara Fernandes" userId="663cf3de9617d588" providerId="LiveId" clId="{3B27595F-788B-43A8-BC19-B0A17F7CB2BD}" dt="2026-07-01T21:41:31.049" v="635" actId="20577"/>
+        <pc:sldMkLst>
+          <pc:docMk/>
+          <pc:sldMk cId="4222430810" sldId="263"/>
+        </pc:sldMkLst>
+        <pc:spChg chg="mod">
+          <ac:chgData name="Ana Clara Fernandes" userId="663cf3de9617d588" providerId="LiveId" clId="{3B27595F-788B-43A8-BC19-B0A17F7CB2BD}" dt="2026-07-01T21:41:31.049" v="635" actId="20577"/>
+          <ac:spMkLst>
+            <pc:docMk/>
+            <pc:sldMk cId="4222430810" sldId="263"/>
+            <ac:spMk id="3" creationId="{D569387B-9F53-6830-85ED-349710E6A321}"/>
+          </ac:spMkLst>
+        </pc:spChg>
+        <pc:spChg chg="del mod">
+          <ac:chgData name="Ana Clara Fernandes" userId="663cf3de9617d588" providerId="LiveId" clId="{3B27595F-788B-43A8-BC19-B0A17F7CB2BD}" dt="2026-07-01T21:37:29.152" v="583" actId="478"/>
+          <ac:spMkLst>
+            <pc:docMk/>
+            <pc:sldMk cId="4222430810" sldId="263"/>
+            <ac:spMk id="26" creationId="{12E01F68-198C-D863-D22C-6FDCB505FD2E}"/>
+          </ac:spMkLst>
+        </pc:spChg>
+        <pc:spChg chg="del">
+          <ac:chgData name="Ana Clara Fernandes" userId="663cf3de9617d588" providerId="LiveId" clId="{3B27595F-788B-43A8-BC19-B0A17F7CB2BD}" dt="2026-07-01T21:37:23.698" v="580" actId="478"/>
+          <ac:spMkLst>
+            <pc:docMk/>
+            <pc:sldMk cId="4222430810" sldId="263"/>
+            <ac:spMk id="27" creationId="{95EC51DC-0808-604A-7A1F-6217BA6E9BB2}"/>
+          </ac:spMkLst>
+        </pc:spChg>
+        <pc:spChg chg="del">
+          <ac:chgData name="Ana Clara Fernandes" userId="663cf3de9617d588" providerId="LiveId" clId="{3B27595F-788B-43A8-BC19-B0A17F7CB2BD}" dt="2026-07-01T21:37:24.377" v="581" actId="478"/>
+          <ac:spMkLst>
+            <pc:docMk/>
+            <pc:sldMk cId="4222430810" sldId="263"/>
+            <ac:spMk id="32" creationId="{5ED90BEC-7DFD-6273-2AD4-F9EEE936ADDE}"/>
+          </ac:spMkLst>
+        </pc:spChg>
+        <pc:picChg chg="add mod">
+          <ac:chgData name="Ana Clara Fernandes" userId="663cf3de9617d588" providerId="LiveId" clId="{3B27595F-788B-43A8-BC19-B0A17F7CB2BD}" dt="2026-07-01T21:40:12.239" v="634" actId="14100"/>
+          <ac:picMkLst>
+            <pc:docMk/>
+            <pc:sldMk cId="4222430810" sldId="263"/>
+            <ac:picMk id="4" creationId="{57B8D5D3-D1D3-B699-040A-D0882F698139}"/>
+          </ac:picMkLst>
+        </pc:picChg>
+        <pc:picChg chg="add mod">
+          <ac:chgData name="Ana Clara Fernandes" userId="663cf3de9617d588" providerId="LiveId" clId="{3B27595F-788B-43A8-BC19-B0A17F7CB2BD}" dt="2026-07-01T21:40:06.101" v="631" actId="14100"/>
+          <ac:picMkLst>
+            <pc:docMk/>
+            <pc:sldMk cId="4222430810" sldId="263"/>
+            <ac:picMk id="5" creationId="{F35195A6-19B2-D128-99B9-BA213A3F01FE}"/>
+          </ac:picMkLst>
+        </pc:picChg>
+        <pc:picChg chg="del">
+          <ac:chgData name="Ana Clara Fernandes" userId="663cf3de9617d588" providerId="LiveId" clId="{3B27595F-788B-43A8-BC19-B0A17F7CB2BD}" dt="2026-07-01T21:37:20.833" v="579" actId="478"/>
+          <ac:picMkLst>
+            <pc:docMk/>
+            <pc:sldMk cId="4222430810" sldId="263"/>
+            <ac:picMk id="31" creationId="{56402FC9-CC6E-4FE4-AC59-DA71639DE6B1}"/>
+          </ac:picMkLst>
+        </pc:picChg>
+      </pc:sldChg>
+    </pc:docChg>
+  </pc:docChgLst>
+</pc:chgInfo>
 </file>
 
 <file path=ppt/charts/chart1.xml><?xml version="1.0" encoding="utf-8"?>
@@ -1563,6 +2078,222 @@
 </p:notes>
 </file>
 
+<file path=ppt/notesSlides/notesSlide6.xml><?xml version="1.0" encoding="utf-8"?>
+<p:notes xmlns:a="http://schemas.openxmlformats.org/drawingml/2006/main" xmlns:r="http://schemas.openxmlformats.org/officeDocument/2006/relationships" xmlns:p="http://schemas.openxmlformats.org/presentationml/2006/main">
+  <p:cSld>
+    <p:spTree>
+      <p:nvGrpSpPr>
+        <p:cNvPr id="1" name="">
+          <a:extLst>
+            <a:ext uri="{FF2B5EF4-FFF2-40B4-BE49-F238E27FC236}">
+              <a16:creationId xmlns:a16="http://schemas.microsoft.com/office/drawing/2014/main" id="{FD412D8F-06B2-7257-06C8-A21AFA20D130}"/>
+            </a:ext>
+          </a:extLst>
+        </p:cNvPr>
+        <p:cNvGrpSpPr/>
+        <p:nvPr/>
+      </p:nvGrpSpPr>
+      <p:grpSpPr>
+        <a:xfrm>
+          <a:off x="0" y="0"/>
+          <a:ext cx="0" cy="0"/>
+          <a:chOff x="0" y="0"/>
+          <a:chExt cx="0" cy="0"/>
+        </a:xfrm>
+      </p:grpSpPr>
+      <p:sp>
+        <p:nvSpPr>
+          <p:cNvPr id="2" name="Slide Image Placeholder 1">
+            <a:extLst>
+              <a:ext uri="{FF2B5EF4-FFF2-40B4-BE49-F238E27FC236}">
+                <a16:creationId xmlns:a16="http://schemas.microsoft.com/office/drawing/2014/main" id="{BB8DC895-81C3-CDCE-084C-446ACEFA6D1B}"/>
+              </a:ext>
+            </a:extLst>
+          </p:cNvPr>
+          <p:cNvSpPr>
+            <a:spLocks noGrp="1" noRot="1" noChangeAspect="1"/>
+          </p:cNvSpPr>
+          <p:nvPr>
+            <p:ph type="sldImg"/>
+          </p:nvPr>
+        </p:nvSpPr>
+        <p:spPr/>
+      </p:sp>
+      <p:sp>
+        <p:nvSpPr>
+          <p:cNvPr id="3" name="Notes Placeholder 2">
+            <a:extLst>
+              <a:ext uri="{FF2B5EF4-FFF2-40B4-BE49-F238E27FC236}">
+                <a16:creationId xmlns:a16="http://schemas.microsoft.com/office/drawing/2014/main" id="{F8C31E5A-BFD1-F1C2-51DC-473FE475A89A}"/>
+              </a:ext>
+            </a:extLst>
+          </p:cNvPr>
+          <p:cNvSpPr>
+            <a:spLocks noGrp="1"/>
+          </p:cNvSpPr>
+          <p:nvPr>
+            <p:ph type="body" idx="1"/>
+          </p:nvPr>
+        </p:nvSpPr>
+        <p:spPr/>
+        <p:txBody>
+          <a:bodyPr/>
+          <a:lstStyle/>
+          <a:p>
+            <a:endParaRPr lang="en-US" dirty="0"/>
+          </a:p>
+        </p:txBody>
+      </p:sp>
+      <p:sp>
+        <p:nvSpPr>
+          <p:cNvPr id="4" name="Slide Number Placeholder 3">
+            <a:extLst>
+              <a:ext uri="{FF2B5EF4-FFF2-40B4-BE49-F238E27FC236}">
+                <a16:creationId xmlns:a16="http://schemas.microsoft.com/office/drawing/2014/main" id="{210EFB41-C7FA-C6A8-830C-8B284D7A5BAD}"/>
+              </a:ext>
+            </a:extLst>
+          </p:cNvPr>
+          <p:cNvSpPr>
+            <a:spLocks noGrp="1"/>
+          </p:cNvSpPr>
+          <p:nvPr>
+            <p:ph type="sldNum" sz="quarter" idx="10"/>
+          </p:nvPr>
+        </p:nvSpPr>
+        <p:spPr/>
+        <p:txBody>
+          <a:bodyPr/>
+          <a:lstStyle/>
+          <a:p>
+            <a:fld id="{F7021451-1387-4CA6-816F-3879F97B5CBC}" type="slidenum">
+              <a:rPr lang="en-US"/>
+              <a:t>6</a:t>
+            </a:fld>
+            <a:endParaRPr lang="en-US"/>
+          </a:p>
+        </p:txBody>
+      </p:sp>
+    </p:spTree>
+    <p:extLst>
+      <p:ext uri="{BB962C8B-B14F-4D97-AF65-F5344CB8AC3E}">
+        <p14:creationId xmlns:p14="http://schemas.microsoft.com/office/powerpoint/2010/main" val="2525636581"/>
+      </p:ext>
+    </p:extLst>
+  </p:cSld>
+  <p:clrMapOvr>
+    <a:masterClrMapping/>
+  </p:clrMapOvr>
+</p:notes>
+</file>
+
+<file path=ppt/notesSlides/notesSlide7.xml><?xml version="1.0" encoding="utf-8"?>
+<p:notes xmlns:a="http://schemas.openxmlformats.org/drawingml/2006/main" xmlns:r="http://schemas.openxmlformats.org/officeDocument/2006/relationships" xmlns:p="http://schemas.openxmlformats.org/presentationml/2006/main">
+  <p:cSld>
+    <p:spTree>
+      <p:nvGrpSpPr>
+        <p:cNvPr id="1" name="">
+          <a:extLst>
+            <a:ext uri="{FF2B5EF4-FFF2-40B4-BE49-F238E27FC236}">
+              <a16:creationId xmlns:a16="http://schemas.microsoft.com/office/drawing/2014/main" id="{4CB17F04-8A32-4CF0-E1E3-D8158D50DA30}"/>
+            </a:ext>
+          </a:extLst>
+        </p:cNvPr>
+        <p:cNvGrpSpPr/>
+        <p:nvPr/>
+      </p:nvGrpSpPr>
+      <p:grpSpPr>
+        <a:xfrm>
+          <a:off x="0" y="0"/>
+          <a:ext cx="0" cy="0"/>
+          <a:chOff x="0" y="0"/>
+          <a:chExt cx="0" cy="0"/>
+        </a:xfrm>
+      </p:grpSpPr>
+      <p:sp>
+        <p:nvSpPr>
+          <p:cNvPr id="2" name="Slide Image Placeholder 1">
+            <a:extLst>
+              <a:ext uri="{FF2B5EF4-FFF2-40B4-BE49-F238E27FC236}">
+                <a16:creationId xmlns:a16="http://schemas.microsoft.com/office/drawing/2014/main" id="{DA616C69-F528-9402-09F1-E7FB9026677C}"/>
+              </a:ext>
+            </a:extLst>
+          </p:cNvPr>
+          <p:cNvSpPr>
+            <a:spLocks noGrp="1" noRot="1" noChangeAspect="1"/>
+          </p:cNvSpPr>
+          <p:nvPr>
+            <p:ph type="sldImg"/>
+          </p:nvPr>
+        </p:nvSpPr>
+        <p:spPr/>
+      </p:sp>
+      <p:sp>
+        <p:nvSpPr>
+          <p:cNvPr id="3" name="Notes Placeholder 2">
+            <a:extLst>
+              <a:ext uri="{FF2B5EF4-FFF2-40B4-BE49-F238E27FC236}">
+                <a16:creationId xmlns:a16="http://schemas.microsoft.com/office/drawing/2014/main" id="{55A6AE7A-28AC-35DC-F28A-EDADD70AD0A3}"/>
+              </a:ext>
+            </a:extLst>
+          </p:cNvPr>
+          <p:cNvSpPr>
+            <a:spLocks noGrp="1"/>
+          </p:cNvSpPr>
+          <p:nvPr>
+            <p:ph type="body" idx="1"/>
+          </p:nvPr>
+        </p:nvSpPr>
+        <p:spPr/>
+        <p:txBody>
+          <a:bodyPr/>
+          <a:lstStyle/>
+          <a:p>
+            <a:endParaRPr lang="en-US" dirty="0"/>
+          </a:p>
+        </p:txBody>
+      </p:sp>
+      <p:sp>
+        <p:nvSpPr>
+          <p:cNvPr id="4" name="Slide Number Placeholder 3">
+            <a:extLst>
+              <a:ext uri="{FF2B5EF4-FFF2-40B4-BE49-F238E27FC236}">
+                <a16:creationId xmlns:a16="http://schemas.microsoft.com/office/drawing/2014/main" id="{FAB6B26A-2A26-6F4B-1DE4-F9A2496E1F6A}"/>
+              </a:ext>
+            </a:extLst>
+          </p:cNvPr>
+          <p:cNvSpPr>
+            <a:spLocks noGrp="1"/>
+          </p:cNvSpPr>
+          <p:nvPr>
+            <p:ph type="sldNum" sz="quarter" idx="10"/>
+          </p:nvPr>
+        </p:nvSpPr>
+        <p:spPr/>
+        <p:txBody>
+          <a:bodyPr/>
+          <a:lstStyle/>
+          <a:p>
+            <a:fld id="{F7021451-1387-4CA6-816F-3879F97B5CBC}" type="slidenum">
+              <a:rPr lang="en-US"/>
+              <a:t>7</a:t>
+            </a:fld>
+            <a:endParaRPr lang="en-US"/>
+          </a:p>
+        </p:txBody>
+      </p:sp>
+    </p:spTree>
+    <p:extLst>
+      <p:ext uri="{BB962C8B-B14F-4D97-AF65-F5344CB8AC3E}">
+        <p14:creationId xmlns:p14="http://schemas.microsoft.com/office/powerpoint/2010/main" val="775697246"/>
+      </p:ext>
+    </p:extLst>
+  </p:cSld>
+  <p:clrMapOvr>
+    <a:masterClrMapping/>
+  </p:clrMapOvr>
+</p:notes>
+</file>
+
 <file path=ppt/slideLayouts/slideLayout1.xml><?xml version="1.0" encoding="utf-8"?>
 <p:sldLayout xmlns:a="http://schemas.openxmlformats.org/drawingml/2006/main" xmlns:r="http://schemas.openxmlformats.org/officeDocument/2006/relationships" xmlns:p="http://schemas.openxmlformats.org/presentationml/2006/main" preserve="1">
   <p:cSld name="DEFAULT">
@@ -2438,45 +3169,6 @@
       </p:sp>
       <p:sp>
         <p:nvSpPr>
-          <p:cNvPr id="17" name="Text 15"/>
-          <p:cNvSpPr/>
-          <p:nvPr/>
-        </p:nvSpPr>
-        <p:spPr>
-          <a:xfrm>
-            <a:off x="457200" y="4800600"/>
-            <a:ext cx="8229600" cy="274320"/>
-          </a:xfrm>
-          <a:prstGeom prst="rect">
-            <a:avLst/>
-          </a:prstGeom>
-          <a:noFill/>
-          <a:ln/>
-        </p:spPr>
-        <p:txBody>
-          <a:bodyPr wrap="square" lIns="0" tIns="0" rIns="0" bIns="0" rtlCol="0" anchor="ctr"/>
-          <a:lstStyle/>
-          <a:p>
-            <a:pPr marL="0" indent="0" algn="r">
-              <a:buNone/>
-            </a:pPr>
-            <a:r>
-              <a:rPr lang="en-US" sz="1000" dirty="0">
-                <a:solidFill>
-                  <a:srgbClr val="6B7280"/>
-                </a:solidFill>
-                <a:latin typeface="Calibri" pitchFamily="34" charset="0"/>
-                <a:ea typeface="Calibri" pitchFamily="34" charset="-122"/>
-                <a:cs typeface="Calibri" pitchFamily="34" charset="-120"/>
-              </a:rPr>
-              <a:t>Ana Clara  ·  Case Técnico Data Science</a:t>
-            </a:r>
-            <a:endParaRPr lang="en-US" sz="1000" dirty="0"/>
-          </a:p>
-        </p:txBody>
-      </p:sp>
-      <p:sp>
-        <p:nvSpPr>
           <p:cNvPr id="18" name="CaixaDeTexto 17">
             <a:extLst>
               <a:ext uri="{FF2B5EF4-FFF2-40B4-BE49-F238E27FC236}">
@@ -2509,23 +3201,7 @@
                   <a:schemeClr val="bg1"/>
                 </a:solidFill>
               </a:rPr>
-              <a:t>Case </a:t>
-            </a:r>
-            <a:r>
-              <a:rPr lang="pt-BR" dirty="0" err="1">
-                <a:solidFill>
-                  <a:schemeClr val="bg1"/>
-                </a:solidFill>
-              </a:rPr>
-              <a:t>Tecnico</a:t>
-            </a:r>
-            <a:r>
-              <a:rPr lang="pt-BR" dirty="0">
-                <a:solidFill>
-                  <a:schemeClr val="bg1"/>
-                </a:solidFill>
-              </a:rPr>
-              <a:t>: Ana Clara Aragão Fernandes</a:t>
+              <a:t>Case Técnico: Ana Clara Aragão Fernandes</a:t>
             </a:r>
           </a:p>
         </p:txBody>
@@ -2682,7 +3358,7 @@
         <p:spPr>
           <a:xfrm>
             <a:off x="457200" y="1600200"/>
-            <a:ext cx="3931920" cy="2194560"/>
+            <a:ext cx="3931920" cy="1243584"/>
           </a:xfrm>
           <a:prstGeom prst="rect">
             <a:avLst/>
@@ -3168,7 +3844,106 @@
                 <a:ea typeface="Calibri" pitchFamily="34" charset="-122"/>
                 <a:cs typeface="Calibri" pitchFamily="34" charset="-120"/>
               </a:rPr>
-              <a:t>BOGO é uniformemente inferior ao Discount em todos os segmentos</a:t>
+              <a:t>BOGO é uniformemente inferior ao Discount em todos </a:t>
+            </a:r>
+            <a:r>
+              <a:rPr lang="en-US" sz="1100" dirty="0" err="1">
+                <a:solidFill>
+                  <a:srgbClr val="1A1A1A"/>
+                </a:solidFill>
+                <a:latin typeface="Calibri" pitchFamily="34" charset="0"/>
+                <a:ea typeface="Calibri" pitchFamily="34" charset="-122"/>
+                <a:cs typeface="Calibri" pitchFamily="34" charset="-120"/>
+              </a:rPr>
+              <a:t>os</a:t>
+            </a:r>
+            <a:r>
+              <a:rPr lang="en-US" sz="1100" dirty="0">
+                <a:solidFill>
+                  <a:srgbClr val="1A1A1A"/>
+                </a:solidFill>
+                <a:latin typeface="Calibri" pitchFamily="34" charset="0"/>
+                <a:ea typeface="Calibri" pitchFamily="34" charset="-122"/>
+                <a:cs typeface="Calibri" pitchFamily="34" charset="-120"/>
+              </a:rPr>
+              <a:t> </a:t>
+            </a:r>
+            <a:r>
+              <a:rPr lang="en-US" sz="1100" dirty="0" err="1">
+                <a:solidFill>
+                  <a:srgbClr val="1A1A1A"/>
+                </a:solidFill>
+                <a:latin typeface="Calibri" pitchFamily="34" charset="0"/>
+                <a:ea typeface="Calibri" pitchFamily="34" charset="-122"/>
+                <a:cs typeface="Calibri" pitchFamily="34" charset="-120"/>
+              </a:rPr>
+              <a:t>segmentos</a:t>
+            </a:r>
+            <a:r>
+              <a:rPr lang="en-US" sz="1100" dirty="0">
+                <a:solidFill>
+                  <a:srgbClr val="1A1A1A"/>
+                </a:solidFill>
+                <a:latin typeface="Calibri" pitchFamily="34" charset="0"/>
+                <a:ea typeface="Calibri" pitchFamily="34" charset="-122"/>
+                <a:cs typeface="Calibri" pitchFamily="34" charset="-120"/>
+              </a:rPr>
+              <a:t> </a:t>
+            </a:r>
+            <a:r>
+              <a:rPr lang="en-US" sz="1100" dirty="0" err="1">
+                <a:solidFill>
+                  <a:srgbClr val="1A1A1A"/>
+                </a:solidFill>
+                <a:latin typeface="Calibri" pitchFamily="34" charset="0"/>
+                <a:ea typeface="Calibri" pitchFamily="34" charset="-122"/>
+                <a:cs typeface="Calibri" pitchFamily="34" charset="-120"/>
+              </a:rPr>
+              <a:t>na</a:t>
+            </a:r>
+            <a:r>
+              <a:rPr lang="en-US" sz="1100" dirty="0">
+                <a:solidFill>
+                  <a:srgbClr val="1A1A1A"/>
+                </a:solidFill>
+                <a:latin typeface="Calibri" pitchFamily="34" charset="0"/>
+                <a:ea typeface="Calibri" pitchFamily="34" charset="-122"/>
+                <a:cs typeface="Calibri" pitchFamily="34" charset="-120"/>
+              </a:rPr>
+              <a:t> </a:t>
+            </a:r>
+            <a:r>
+              <a:rPr lang="en-US" sz="1100" dirty="0" err="1">
+                <a:solidFill>
+                  <a:srgbClr val="1A1A1A"/>
+                </a:solidFill>
+                <a:latin typeface="Calibri" pitchFamily="34" charset="0"/>
+                <a:ea typeface="Calibri" pitchFamily="34" charset="-122"/>
+                <a:cs typeface="Calibri" pitchFamily="34" charset="-120"/>
+              </a:rPr>
+              <a:t>amostra</a:t>
+            </a:r>
+            <a:r>
+              <a:rPr lang="en-US" sz="1100" dirty="0">
+                <a:solidFill>
+                  <a:srgbClr val="1A1A1A"/>
+                </a:solidFill>
+                <a:latin typeface="Calibri" pitchFamily="34" charset="0"/>
+                <a:ea typeface="Calibri" pitchFamily="34" charset="-122"/>
+                <a:cs typeface="Calibri" pitchFamily="34" charset="-120"/>
+              </a:rPr>
+              <a:t> </a:t>
+            </a:r>
+            <a:r>
+              <a:rPr lang="en-US" sz="1100" dirty="0" err="1">
+                <a:solidFill>
+                  <a:srgbClr val="1A1A1A"/>
+                </a:solidFill>
+                <a:latin typeface="Calibri" pitchFamily="34" charset="0"/>
+                <a:ea typeface="Calibri" pitchFamily="34" charset="-122"/>
+                <a:cs typeface="Calibri" pitchFamily="34" charset="-120"/>
+              </a:rPr>
+              <a:t>analisada</a:t>
             </a:r>
             <a:endParaRPr lang="en-US" sz="1100" dirty="0"/>
           </a:p>
@@ -3241,9 +4016,364 @@
                 <a:ea typeface="Calibri" pitchFamily="34" charset="-122"/>
                 <a:cs typeface="Calibri" pitchFamily="34" charset="-120"/>
               </a:rPr>
-              <a:t>💡  A maior alavanca de ROI é para quem enviar — não qual oferta enviar</a:t>
+              <a:t>💡  A maior alavanca de ROI é para quem </a:t>
+            </a:r>
+            <a:r>
+              <a:rPr lang="en-US" sz="1200" b="1" dirty="0" err="1">
+                <a:solidFill>
+                  <a:srgbClr val="FFFFFF"/>
+                </a:solidFill>
+                <a:latin typeface="Calibri" pitchFamily="34" charset="0"/>
+                <a:ea typeface="Calibri" pitchFamily="34" charset="-122"/>
+                <a:cs typeface="Calibri" pitchFamily="34" charset="-120"/>
+              </a:rPr>
+              <a:t>enviar</a:t>
             </a:r>
             <a:endParaRPr lang="en-US" sz="1200" dirty="0"/>
+          </a:p>
+        </p:txBody>
+      </p:sp>
+      <p:sp>
+        <p:nvSpPr>
+          <p:cNvPr id="18" name="Text 2">
+            <a:extLst>
+              <a:ext uri="{FF2B5EF4-FFF2-40B4-BE49-F238E27FC236}">
+                <a16:creationId xmlns:a16="http://schemas.microsoft.com/office/drawing/2014/main" id="{7B870B82-C49A-5DA1-26DE-4C4758895C56}"/>
+              </a:ext>
+            </a:extLst>
+          </p:cNvPr>
+          <p:cNvSpPr/>
+          <p:nvPr/>
+        </p:nvSpPr>
+        <p:spPr>
+          <a:xfrm>
+            <a:off x="457200" y="3090672"/>
+            <a:ext cx="3840480" cy="320040"/>
+          </a:xfrm>
+          <a:prstGeom prst="rect">
+            <a:avLst/>
+          </a:prstGeom>
+          <a:noFill/>
+          <a:ln/>
+        </p:spPr>
+        <p:txBody>
+          <a:bodyPr wrap="square" lIns="0" tIns="0" rIns="0" bIns="0" rtlCol="0" anchor="ctr"/>
+          <a:lstStyle/>
+          <a:p>
+            <a:pPr marL="0" indent="0">
+              <a:buNone/>
+            </a:pPr>
+            <a:r>
+              <a:rPr lang="en-US" sz="1100" b="1" kern="0" spc="200" dirty="0">
+                <a:solidFill>
+                  <a:srgbClr val="EA1D2C"/>
+                </a:solidFill>
+                <a:latin typeface="Calibri" pitchFamily="34" charset="0"/>
+                <a:ea typeface="Calibri" pitchFamily="34" charset="-122"/>
+                <a:cs typeface="Calibri" pitchFamily="34" charset="-120"/>
+              </a:rPr>
+              <a:t>PROPOSTA</a:t>
+            </a:r>
+            <a:endParaRPr lang="en-US" sz="1100" dirty="0"/>
+          </a:p>
+        </p:txBody>
+      </p:sp>
+      <p:sp>
+        <p:nvSpPr>
+          <p:cNvPr id="19" name="Text 3">
+            <a:extLst>
+              <a:ext uri="{FF2B5EF4-FFF2-40B4-BE49-F238E27FC236}">
+                <a16:creationId xmlns:a16="http://schemas.microsoft.com/office/drawing/2014/main" id="{307EF5C3-2FAB-9FCC-DE4F-4733EB3157E2}"/>
+              </a:ext>
+            </a:extLst>
+          </p:cNvPr>
+          <p:cNvSpPr/>
+          <p:nvPr/>
+        </p:nvSpPr>
+        <p:spPr>
+          <a:xfrm>
+            <a:off x="457200" y="3461520"/>
+            <a:ext cx="4051548" cy="785560"/>
+          </a:xfrm>
+          <a:prstGeom prst="rect">
+            <a:avLst/>
+          </a:prstGeom>
+          <a:noFill/>
+          <a:ln/>
+        </p:spPr>
+        <p:txBody>
+          <a:bodyPr wrap="square" lIns="0" tIns="0" rIns="0" bIns="0" rtlCol="0" anchor="t"/>
+          <a:lstStyle/>
+          <a:p>
+            <a:pPr marL="0" indent="0">
+              <a:buNone/>
+            </a:pPr>
+            <a:r>
+              <a:rPr lang="en-US" sz="1300" b="1" dirty="0">
+                <a:solidFill>
+                  <a:srgbClr val="EA1D2C"/>
+                </a:solidFill>
+                <a:latin typeface="Calibri" pitchFamily="34" charset="0"/>
+                <a:ea typeface="Calibri" pitchFamily="34" charset="-122"/>
+                <a:cs typeface="Calibri" pitchFamily="34" charset="-120"/>
+              </a:rPr>
+              <a:t>①  </a:t>
+            </a:r>
+            <a:r>
+              <a:rPr lang="en-US" sz="1300" dirty="0" err="1">
+                <a:solidFill>
+                  <a:srgbClr val="1A1A1A"/>
+                </a:solidFill>
+                <a:latin typeface="Calibri" pitchFamily="34" charset="0"/>
+                <a:ea typeface="Calibri" pitchFamily="34" charset="-122"/>
+                <a:cs typeface="Calibri" pitchFamily="34" charset="-120"/>
+              </a:rPr>
+              <a:t>Validação</a:t>
+            </a:r>
+            <a:r>
+              <a:rPr lang="en-US" sz="1300" dirty="0">
+                <a:solidFill>
+                  <a:srgbClr val="1A1A1A"/>
+                </a:solidFill>
+                <a:latin typeface="Calibri" pitchFamily="34" charset="0"/>
+                <a:ea typeface="Calibri" pitchFamily="34" charset="-122"/>
+                <a:cs typeface="Calibri" pitchFamily="34" charset="-120"/>
+              </a:rPr>
+              <a:t> de </a:t>
+            </a:r>
+            <a:r>
+              <a:rPr lang="en-US" sz="1300" dirty="0" err="1">
+                <a:solidFill>
+                  <a:srgbClr val="1A1A1A"/>
+                </a:solidFill>
+                <a:latin typeface="Calibri" pitchFamily="34" charset="0"/>
+                <a:ea typeface="Calibri" pitchFamily="34" charset="-122"/>
+                <a:cs typeface="Calibri" pitchFamily="34" charset="-120"/>
+              </a:rPr>
+              <a:t>impacto</a:t>
+            </a:r>
+            <a:r>
+              <a:rPr lang="en-US" sz="1300" dirty="0">
+                <a:solidFill>
+                  <a:srgbClr val="1A1A1A"/>
+                </a:solidFill>
+                <a:latin typeface="Calibri" pitchFamily="34" charset="0"/>
+                <a:ea typeface="Calibri" pitchFamily="34" charset="-122"/>
+                <a:cs typeface="Calibri" pitchFamily="34" charset="-120"/>
+              </a:rPr>
+              <a:t> (testes A/B)
+</a:t>
+            </a:r>
+            <a:r>
+              <a:rPr lang="en-US" sz="1300" b="1" dirty="0">
+                <a:solidFill>
+                  <a:srgbClr val="EA1D2C"/>
+                </a:solidFill>
+                <a:latin typeface="Calibri" pitchFamily="34" charset="0"/>
+                <a:ea typeface="Calibri" pitchFamily="34" charset="-122"/>
+                <a:cs typeface="Calibri" pitchFamily="34" charset="-120"/>
+              </a:rPr>
+              <a:t>② </a:t>
+            </a:r>
+            <a:r>
+              <a:rPr lang="en-US" sz="1300" dirty="0">
+                <a:solidFill>
+                  <a:srgbClr val="EA1D2C"/>
+                </a:solidFill>
+                <a:latin typeface="Calibri" pitchFamily="34" charset="0"/>
+                <a:ea typeface="Calibri" pitchFamily="34" charset="-122"/>
+                <a:cs typeface="Calibri" pitchFamily="34" charset="-120"/>
+              </a:rPr>
+              <a:t> </a:t>
+            </a:r>
+            <a:r>
+              <a:rPr lang="en-US" sz="1300" dirty="0" err="1">
+                <a:solidFill>
+                  <a:srgbClr val="1A1A1A"/>
+                </a:solidFill>
+                <a:latin typeface="Calibri" pitchFamily="34" charset="0"/>
+                <a:ea typeface="Calibri" pitchFamily="34" charset="-122"/>
+                <a:cs typeface="Calibri" pitchFamily="34" charset="-120"/>
+              </a:rPr>
+              <a:t>Implementação</a:t>
+            </a:r>
+            <a:r>
+              <a:rPr lang="en-US" sz="1300" dirty="0">
+                <a:solidFill>
+                  <a:srgbClr val="1A1A1A"/>
+                </a:solidFill>
+                <a:latin typeface="Calibri" pitchFamily="34" charset="0"/>
+                <a:ea typeface="Calibri" pitchFamily="34" charset="-122"/>
+                <a:cs typeface="Calibri" pitchFamily="34" charset="-120"/>
+              </a:rPr>
+              <a:t> do Modelo S-Learner </a:t>
+            </a:r>
+            <a:r>
+              <a:rPr lang="en-US" sz="1300" dirty="0" err="1">
+                <a:solidFill>
+                  <a:srgbClr val="1A1A1A"/>
+                </a:solidFill>
+                <a:latin typeface="Calibri" pitchFamily="34" charset="0"/>
+                <a:ea typeface="Calibri" pitchFamily="34" charset="-122"/>
+                <a:cs typeface="Calibri" pitchFamily="34" charset="-120"/>
+              </a:rPr>
+              <a:t>que</a:t>
+            </a:r>
+            <a:r>
+              <a:rPr lang="en-US" sz="1300" dirty="0">
+                <a:solidFill>
+                  <a:srgbClr val="1A1A1A"/>
+                </a:solidFill>
+                <a:latin typeface="Calibri" pitchFamily="34" charset="0"/>
+                <a:ea typeface="Calibri" pitchFamily="34" charset="-122"/>
+                <a:cs typeface="Calibri" pitchFamily="34" charset="-120"/>
+              </a:rPr>
+              <a:t> </a:t>
+            </a:r>
+            <a:r>
+              <a:rPr lang="en-US" sz="1300" dirty="0" err="1">
+                <a:solidFill>
+                  <a:srgbClr val="1A1A1A"/>
+                </a:solidFill>
+                <a:latin typeface="Calibri" pitchFamily="34" charset="0"/>
+                <a:ea typeface="Calibri" pitchFamily="34" charset="-122"/>
+                <a:cs typeface="Calibri" pitchFamily="34" charset="-120"/>
+              </a:rPr>
+              <a:t>valida</a:t>
+            </a:r>
+            <a:r>
+              <a:rPr lang="en-US" sz="1300" dirty="0">
+                <a:solidFill>
+                  <a:srgbClr val="1A1A1A"/>
+                </a:solidFill>
+                <a:latin typeface="Calibri" pitchFamily="34" charset="0"/>
+                <a:ea typeface="Calibri" pitchFamily="34" charset="-122"/>
+                <a:cs typeface="Calibri" pitchFamily="34" charset="-120"/>
+              </a:rPr>
+              <a:t> </a:t>
+            </a:r>
+            <a:r>
+              <a:rPr lang="en-US" sz="1300" dirty="0" err="1">
+                <a:solidFill>
+                  <a:srgbClr val="1A1A1A"/>
+                </a:solidFill>
+                <a:latin typeface="Calibri" pitchFamily="34" charset="0"/>
+                <a:ea typeface="Calibri" pitchFamily="34" charset="-122"/>
+                <a:cs typeface="Calibri" pitchFamily="34" charset="-120"/>
+              </a:rPr>
+              <a:t>conjuntamente</a:t>
+            </a:r>
+            <a:r>
+              <a:rPr lang="en-US" sz="1300" dirty="0">
+                <a:solidFill>
+                  <a:srgbClr val="1A1A1A"/>
+                </a:solidFill>
+                <a:latin typeface="Calibri" pitchFamily="34" charset="0"/>
+                <a:ea typeface="Calibri" pitchFamily="34" charset="-122"/>
+                <a:cs typeface="Calibri" pitchFamily="34" charset="-120"/>
+              </a:rPr>
+              <a:t> o </a:t>
+            </a:r>
+            <a:r>
+              <a:rPr lang="en-US" sz="1300" dirty="0" err="1">
+                <a:solidFill>
+                  <a:srgbClr val="1A1A1A"/>
+                </a:solidFill>
+                <a:latin typeface="Calibri" pitchFamily="34" charset="0"/>
+                <a:ea typeface="Calibri" pitchFamily="34" charset="-122"/>
+                <a:cs typeface="Calibri" pitchFamily="34" charset="-120"/>
+              </a:rPr>
+              <a:t>impacto</a:t>
+            </a:r>
+            <a:r>
+              <a:rPr lang="en-US" sz="1300" dirty="0">
+                <a:solidFill>
+                  <a:srgbClr val="1A1A1A"/>
+                </a:solidFill>
+                <a:latin typeface="Calibri" pitchFamily="34" charset="0"/>
+                <a:ea typeface="Calibri" pitchFamily="34" charset="-122"/>
+                <a:cs typeface="Calibri" pitchFamily="34" charset="-120"/>
+              </a:rPr>
+              <a:t> de </a:t>
+            </a:r>
+            <a:r>
+              <a:rPr lang="en-US" sz="1300" dirty="0" err="1">
+                <a:solidFill>
+                  <a:srgbClr val="1A1A1A"/>
+                </a:solidFill>
+                <a:latin typeface="Calibri" pitchFamily="34" charset="0"/>
+                <a:ea typeface="Calibri" pitchFamily="34" charset="-122"/>
+                <a:cs typeface="Calibri" pitchFamily="34" charset="-120"/>
+              </a:rPr>
+              <a:t>conversão</a:t>
+            </a:r>
+            <a:r>
+              <a:rPr lang="en-US" sz="1300" dirty="0">
+                <a:solidFill>
+                  <a:srgbClr val="1A1A1A"/>
+                </a:solidFill>
+                <a:latin typeface="Calibri" pitchFamily="34" charset="0"/>
+                <a:ea typeface="Calibri" pitchFamily="34" charset="-122"/>
+                <a:cs typeface="Calibri" pitchFamily="34" charset="-120"/>
+              </a:rPr>
+              <a:t>
+</a:t>
+            </a:r>
+            <a:r>
+              <a:rPr lang="en-US" sz="1300" b="1" dirty="0">
+                <a:solidFill>
+                  <a:srgbClr val="EA1D2C"/>
+                </a:solidFill>
+                <a:latin typeface="Calibri" pitchFamily="34" charset="0"/>
+                <a:ea typeface="Calibri" pitchFamily="34" charset="-122"/>
+                <a:cs typeface="Calibri" pitchFamily="34" charset="-120"/>
+              </a:rPr>
+              <a:t>③  </a:t>
+            </a:r>
+            <a:r>
+              <a:rPr lang="en-US" sz="1300" dirty="0" err="1">
+                <a:solidFill>
+                  <a:srgbClr val="1A1A1A"/>
+                </a:solidFill>
+                <a:latin typeface="Calibri" pitchFamily="34" charset="0"/>
+                <a:ea typeface="Calibri" pitchFamily="34" charset="-122"/>
+                <a:cs typeface="Calibri" pitchFamily="34" charset="-120"/>
+              </a:rPr>
+              <a:t>Análise</a:t>
+            </a:r>
+            <a:r>
+              <a:rPr lang="en-US" sz="1300" dirty="0">
+                <a:solidFill>
+                  <a:srgbClr val="1A1A1A"/>
+                </a:solidFill>
+                <a:latin typeface="Calibri" pitchFamily="34" charset="0"/>
+                <a:ea typeface="Calibri" pitchFamily="34" charset="-122"/>
+                <a:cs typeface="Calibri" pitchFamily="34" charset="-120"/>
+              </a:rPr>
+              <a:t> de </a:t>
+            </a:r>
+            <a:r>
+              <a:rPr lang="en-US" sz="1300" dirty="0" err="1">
+                <a:solidFill>
+                  <a:srgbClr val="1A1A1A"/>
+                </a:solidFill>
+                <a:latin typeface="Calibri" pitchFamily="34" charset="0"/>
+                <a:ea typeface="Calibri" pitchFamily="34" charset="-122"/>
+                <a:cs typeface="Calibri" pitchFamily="34" charset="-120"/>
+              </a:rPr>
+              <a:t>SureThings</a:t>
+            </a:r>
+            <a:r>
+              <a:rPr lang="en-US" sz="1300" dirty="0">
+                <a:solidFill>
+                  <a:srgbClr val="1A1A1A"/>
+                </a:solidFill>
+                <a:latin typeface="Calibri" pitchFamily="34" charset="0"/>
+                <a:ea typeface="Calibri" pitchFamily="34" charset="-122"/>
+                <a:cs typeface="Calibri" pitchFamily="34" charset="-120"/>
+              </a:rPr>
+              <a:t> com base no S-learner.</a:t>
+            </a:r>
           </a:p>
         </p:txBody>
       </p:sp>
@@ -5017,6 +6147,40 @@
             <a:pPr marL="0" indent="0" algn="ctr">
               <a:buNone/>
             </a:pPr>
+            <a:endParaRPr lang="en-US" sz="1200" dirty="0"/>
+          </a:p>
+        </p:txBody>
+      </p:sp>
+      <p:sp>
+        <p:nvSpPr>
+          <p:cNvPr id="19" name="Text 24">
+            <a:extLst>
+              <a:ext uri="{FF2B5EF4-FFF2-40B4-BE49-F238E27FC236}">
+                <a16:creationId xmlns:a16="http://schemas.microsoft.com/office/drawing/2014/main" id="{366F5EDB-91A4-E90E-2B0D-6A99F579F657}"/>
+              </a:ext>
+            </a:extLst>
+          </p:cNvPr>
+          <p:cNvSpPr/>
+          <p:nvPr/>
+        </p:nvSpPr>
+        <p:spPr>
+          <a:xfrm>
+            <a:off x="228600" y="4584490"/>
+            <a:ext cx="8229600" cy="384048"/>
+          </a:xfrm>
+          <a:prstGeom prst="rect">
+            <a:avLst/>
+          </a:prstGeom>
+          <a:noFill/>
+          <a:ln/>
+        </p:spPr>
+        <p:txBody>
+          <a:bodyPr wrap="square" lIns="0" tIns="0" rIns="0" bIns="0" rtlCol="0" anchor="ctr"/>
+          <a:lstStyle/>
+          <a:p>
+            <a:pPr marL="0" indent="0" algn="ctr">
+              <a:buNone/>
+            </a:pPr>
             <a:r>
               <a:rPr lang="en-US" sz="1200" b="1" dirty="0">
                 <a:solidFill>
@@ -5026,7 +6190,18 @@
                 <a:ea typeface="Calibri" pitchFamily="34" charset="-122"/>
                 <a:cs typeface="Calibri" pitchFamily="34" charset="-120"/>
               </a:rPr>
-              <a:t>💡  Aleatorização confirmada + diferenças reais = S-Learner é metodologicamente válido</a:t>
+              <a:t>💡  Estratégia validada em dados </a:t>
+            </a:r>
+            <a:r>
+              <a:rPr lang="en-US" sz="1200" b="1" dirty="0" err="1">
+                <a:solidFill>
+                  <a:srgbClr val="FFFFFF"/>
+                </a:solidFill>
+                <a:latin typeface="Calibri" pitchFamily="34" charset="0"/>
+                <a:ea typeface="Calibri" pitchFamily="34" charset="-122"/>
+                <a:cs typeface="Calibri" pitchFamily="34" charset="-120"/>
+              </a:rPr>
+              <a:t>experimentais</a:t>
             </a:r>
             <a:endParaRPr lang="en-US" sz="1200" dirty="0"/>
           </a:p>
@@ -5729,7 +6904,13 @@
         <p:nvGraphicFramePr>
           <p:cNvPr id="18" name="Chart 1"/>
           <p:cNvGraphicFramePr/>
-          <p:nvPr/>
+          <p:nvPr>
+            <p:extLst>
+              <p:ext uri="{D42A27DB-BD31-4B8C-83A1-F6EECF244321}">
+                <p14:modId xmlns:p14="http://schemas.microsoft.com/office/powerpoint/2010/main" val="1705260834"/>
+              </p:ext>
+            </p:extLst>
+          </p:nvPr>
         </p:nvGraphicFramePr>
         <p:xfrm>
           <a:off x="4892040" y="1417320"/>
@@ -5980,9 +7161,66 @@
                 <a:ea typeface="Calibri" pitchFamily="34" charset="-122"/>
                 <a:cs typeface="Calibri" pitchFamily="34" charset="-120"/>
               </a:rPr>
-              <a:t>💡  Personalização entrega +5.1 p.p. de conversão e economiza R$20.6k por rodada de campanha</a:t>
+              <a:t>💡  Personalização entrega +5.1 p.p. de conversão e </a:t>
+            </a:r>
+            <a:r>
+              <a:rPr lang="en-US" sz="1200" b="1" dirty="0" err="1">
+                <a:solidFill>
+                  <a:srgbClr val="FFFFFF"/>
+                </a:solidFill>
+                <a:latin typeface="Calibri" pitchFamily="34" charset="0"/>
+                <a:ea typeface="Calibri" pitchFamily="34" charset="-122"/>
+                <a:cs typeface="Calibri" pitchFamily="34" charset="-120"/>
+              </a:rPr>
+              <a:t>economiza</a:t>
+            </a:r>
+            <a:r>
+              <a:rPr lang="en-US" sz="1200" b="1" dirty="0">
+                <a:solidFill>
+                  <a:srgbClr val="FFFFFF"/>
+                </a:solidFill>
+                <a:latin typeface="Calibri" pitchFamily="34" charset="0"/>
+                <a:ea typeface="Calibri" pitchFamily="34" charset="-122"/>
+                <a:cs typeface="Calibri" pitchFamily="34" charset="-120"/>
+              </a:rPr>
+              <a:t> ~R$20.6k por rodada de campanha</a:t>
             </a:r>
             <a:endParaRPr lang="en-US" sz="1200" dirty="0"/>
+          </a:p>
+        </p:txBody>
+      </p:sp>
+      <p:sp>
+        <p:nvSpPr>
+          <p:cNvPr id="24" name="CaixaDeTexto 23">
+            <a:extLst>
+              <a:ext uri="{FF2B5EF4-FFF2-40B4-BE49-F238E27FC236}">
+                <a16:creationId xmlns:a16="http://schemas.microsoft.com/office/drawing/2014/main" id="{3A607922-F542-804B-A109-A340348E6E02}"/>
+              </a:ext>
+            </a:extLst>
+          </p:cNvPr>
+          <p:cNvSpPr txBox="1"/>
+          <p:nvPr/>
+        </p:nvSpPr>
+        <p:spPr>
+          <a:xfrm>
+            <a:off x="6930189" y="4935820"/>
+            <a:ext cx="1930896" cy="253916"/>
+          </a:xfrm>
+          <a:prstGeom prst="rect">
+            <a:avLst/>
+          </a:prstGeom>
+          <a:noFill/>
+        </p:spPr>
+        <p:txBody>
+          <a:bodyPr wrap="square">
+            <a:spAutoFit/>
+          </a:bodyPr>
+          <a:lstStyle/>
+          <a:p>
+            <a:r>
+              <a:rPr lang="pt-BR" sz="1050" dirty="0"/>
+              <a:t>THRESHOLD_SURE_THING = 0,7</a:t>
+            </a:r>
           </a:p>
         </p:txBody>
       </p:sp>
@@ -6234,6 +7472,17 @@
               <a:buNone/>
             </a:pPr>
             <a:r>
+              <a:rPr lang="en-US" sz="1200" b="1" dirty="0" err="1">
+                <a:solidFill>
+                  <a:srgbClr val="1A1A1A"/>
+                </a:solidFill>
+                <a:latin typeface="Calibri" pitchFamily="34" charset="0"/>
+                <a:ea typeface="Calibri" pitchFamily="34" charset="-122"/>
+                <a:cs typeface="Calibri" pitchFamily="34" charset="-120"/>
+              </a:rPr>
+              <a:t>Avaliar</a:t>
+            </a:r>
+            <a:r>
               <a:rPr lang="en-US" sz="1200" b="1" dirty="0">
                 <a:solidFill>
                   <a:srgbClr val="1A1A1A"/>
@@ -6242,7 +7491,51 @@
                 <a:ea typeface="Calibri" pitchFamily="34" charset="-122"/>
                 <a:cs typeface="Calibri" pitchFamily="34" charset="-120"/>
               </a:rPr>
-              <a:t>Descontinuar BOGO
+              <a:t> </a:t>
+            </a:r>
+            <a:r>
+              <a:rPr lang="en-US" sz="1200" b="1" dirty="0" err="1">
+                <a:solidFill>
+                  <a:srgbClr val="1A1A1A"/>
+                </a:solidFill>
+                <a:latin typeface="Calibri" pitchFamily="34" charset="0"/>
+                <a:ea typeface="Calibri" pitchFamily="34" charset="-122"/>
+                <a:cs typeface="Calibri" pitchFamily="34" charset="-120"/>
+              </a:rPr>
+              <a:t>parâmetros</a:t>
+            </a:r>
+            <a:r>
+              <a:rPr lang="en-US" sz="1200" b="1" dirty="0">
+                <a:solidFill>
+                  <a:srgbClr val="1A1A1A"/>
+                </a:solidFill>
+                <a:latin typeface="Calibri" pitchFamily="34" charset="0"/>
+                <a:ea typeface="Calibri" pitchFamily="34" charset="-122"/>
+                <a:cs typeface="Calibri" pitchFamily="34" charset="-120"/>
+              </a:rPr>
+              <a:t> de </a:t>
+            </a:r>
+            <a:r>
+              <a:rPr lang="en-US" sz="1200" b="1" dirty="0" err="1">
+                <a:solidFill>
+                  <a:srgbClr val="1A1A1A"/>
+                </a:solidFill>
+                <a:latin typeface="Calibri" pitchFamily="34" charset="0"/>
+                <a:ea typeface="Calibri" pitchFamily="34" charset="-122"/>
+                <a:cs typeface="Calibri" pitchFamily="34" charset="-120"/>
+              </a:rPr>
+              <a:t>ofertas</a:t>
+            </a:r>
+            <a:r>
+              <a:rPr lang="en-US" sz="1200" b="1" dirty="0">
+                <a:solidFill>
+                  <a:srgbClr val="1A1A1A"/>
+                </a:solidFill>
+                <a:latin typeface="Calibri" pitchFamily="34" charset="0"/>
+                <a:ea typeface="Calibri" pitchFamily="34" charset="-122"/>
+                <a:cs typeface="Calibri" pitchFamily="34" charset="-120"/>
+              </a:rPr>
+              <a:t> BOGO
 </a:t>
             </a:r>
             <a:r>
@@ -6254,7 +7547,249 @@
                 <a:ea typeface="Calibri" pitchFamily="34" charset="-122"/>
                 <a:cs typeface="Calibri" pitchFamily="34" charset="-120"/>
               </a:rPr>
-              <a:t>Nunca recomendado pelo modelo — parâmetros atuais geram performance inferior ao Discount em todos os segmentos</a:t>
+              <a:t>Com base </a:t>
+            </a:r>
+            <a:r>
+              <a:rPr lang="en-US" sz="1000" dirty="0" err="1">
+                <a:solidFill>
+                  <a:srgbClr val="6B7280"/>
+                </a:solidFill>
+                <a:latin typeface="Calibri" pitchFamily="34" charset="0"/>
+                <a:ea typeface="Calibri" pitchFamily="34" charset="-122"/>
+                <a:cs typeface="Calibri" pitchFamily="34" charset="-120"/>
+              </a:rPr>
+              <a:t>na</a:t>
+            </a:r>
+            <a:r>
+              <a:rPr lang="en-US" sz="1000" dirty="0">
+                <a:solidFill>
+                  <a:srgbClr val="6B7280"/>
+                </a:solidFill>
+                <a:latin typeface="Calibri" pitchFamily="34" charset="0"/>
+                <a:ea typeface="Calibri" pitchFamily="34" charset="-122"/>
+                <a:cs typeface="Calibri" pitchFamily="34" charset="-120"/>
+              </a:rPr>
+              <a:t> </a:t>
+            </a:r>
+            <a:r>
+              <a:rPr lang="en-US" sz="1000" dirty="0" err="1">
+                <a:solidFill>
+                  <a:srgbClr val="6B7280"/>
+                </a:solidFill>
+                <a:latin typeface="Calibri" pitchFamily="34" charset="0"/>
+                <a:ea typeface="Calibri" pitchFamily="34" charset="-122"/>
+                <a:cs typeface="Calibri" pitchFamily="34" charset="-120"/>
+              </a:rPr>
+              <a:t>amostra</a:t>
+            </a:r>
+            <a:r>
+              <a:rPr lang="en-US" sz="1000" dirty="0">
+                <a:solidFill>
+                  <a:srgbClr val="6B7280"/>
+                </a:solidFill>
+                <a:latin typeface="Calibri" pitchFamily="34" charset="0"/>
+                <a:ea typeface="Calibri" pitchFamily="34" charset="-122"/>
+                <a:cs typeface="Calibri" pitchFamily="34" charset="-120"/>
+              </a:rPr>
+              <a:t> </a:t>
+            </a:r>
+            <a:r>
+              <a:rPr lang="en-US" sz="1000" dirty="0" err="1">
+                <a:solidFill>
+                  <a:srgbClr val="6B7280"/>
+                </a:solidFill>
+                <a:latin typeface="Calibri" pitchFamily="34" charset="0"/>
+                <a:ea typeface="Calibri" pitchFamily="34" charset="-122"/>
+                <a:cs typeface="Calibri" pitchFamily="34" charset="-120"/>
+              </a:rPr>
+              <a:t>disponibilizada</a:t>
+            </a:r>
+            <a:r>
+              <a:rPr lang="en-US" sz="1000" dirty="0">
+                <a:solidFill>
+                  <a:srgbClr val="6B7280"/>
+                </a:solidFill>
+                <a:latin typeface="Calibri" pitchFamily="34" charset="0"/>
+                <a:ea typeface="Calibri" pitchFamily="34" charset="-122"/>
+                <a:cs typeface="Calibri" pitchFamily="34" charset="-120"/>
+              </a:rPr>
+              <a:t>, BOGO </a:t>
+            </a:r>
+            <a:r>
+              <a:rPr lang="en-US" sz="1000" dirty="0" err="1">
+                <a:solidFill>
+                  <a:srgbClr val="6B7280"/>
+                </a:solidFill>
+                <a:latin typeface="Calibri" pitchFamily="34" charset="0"/>
+                <a:ea typeface="Calibri" pitchFamily="34" charset="-122"/>
+                <a:cs typeface="Calibri" pitchFamily="34" charset="-120"/>
+              </a:rPr>
+              <a:t>não</a:t>
+            </a:r>
+            <a:r>
+              <a:rPr lang="en-US" sz="1000" dirty="0">
+                <a:solidFill>
+                  <a:srgbClr val="6B7280"/>
+                </a:solidFill>
+                <a:latin typeface="Calibri" pitchFamily="34" charset="0"/>
+                <a:ea typeface="Calibri" pitchFamily="34" charset="-122"/>
+                <a:cs typeface="Calibri" pitchFamily="34" charset="-120"/>
+              </a:rPr>
+              <a:t> </a:t>
+            </a:r>
+            <a:r>
+              <a:rPr lang="en-US" sz="1000" dirty="0" err="1">
+                <a:solidFill>
+                  <a:srgbClr val="6B7280"/>
+                </a:solidFill>
+                <a:latin typeface="Calibri" pitchFamily="34" charset="0"/>
+                <a:ea typeface="Calibri" pitchFamily="34" charset="-122"/>
+                <a:cs typeface="Calibri" pitchFamily="34" charset="-120"/>
+              </a:rPr>
+              <a:t>foi</a:t>
+            </a:r>
+            <a:r>
+              <a:rPr lang="en-US" sz="1000" dirty="0">
+                <a:solidFill>
+                  <a:srgbClr val="6B7280"/>
+                </a:solidFill>
+                <a:latin typeface="Calibri" pitchFamily="34" charset="0"/>
+                <a:ea typeface="Calibri" pitchFamily="34" charset="-122"/>
+                <a:cs typeface="Calibri" pitchFamily="34" charset="-120"/>
+              </a:rPr>
+              <a:t> </a:t>
+            </a:r>
+            <a:r>
+              <a:rPr lang="en-US" sz="1000" dirty="0" err="1">
+                <a:solidFill>
+                  <a:srgbClr val="6B7280"/>
+                </a:solidFill>
+                <a:latin typeface="Calibri" pitchFamily="34" charset="0"/>
+                <a:ea typeface="Calibri" pitchFamily="34" charset="-122"/>
+                <a:cs typeface="Calibri" pitchFamily="34" charset="-120"/>
+              </a:rPr>
+              <a:t>recomendado</a:t>
+            </a:r>
+            <a:r>
+              <a:rPr lang="en-US" sz="1000" dirty="0">
+                <a:solidFill>
+                  <a:srgbClr val="6B7280"/>
+                </a:solidFill>
+                <a:latin typeface="Calibri" pitchFamily="34" charset="0"/>
+                <a:ea typeface="Calibri" pitchFamily="34" charset="-122"/>
+                <a:cs typeface="Calibri" pitchFamily="34" charset="-120"/>
+              </a:rPr>
+              <a:t> </a:t>
+            </a:r>
+            <a:r>
+              <a:rPr lang="en-US" sz="1000" dirty="0" err="1">
+                <a:solidFill>
+                  <a:srgbClr val="6B7280"/>
+                </a:solidFill>
+                <a:latin typeface="Calibri" pitchFamily="34" charset="0"/>
+                <a:ea typeface="Calibri" pitchFamily="34" charset="-122"/>
+                <a:cs typeface="Calibri" pitchFamily="34" charset="-120"/>
+              </a:rPr>
+              <a:t>pelo</a:t>
+            </a:r>
+            <a:r>
+              <a:rPr lang="en-US" sz="1000" dirty="0">
+                <a:solidFill>
+                  <a:srgbClr val="6B7280"/>
+                </a:solidFill>
+                <a:latin typeface="Calibri" pitchFamily="34" charset="0"/>
+                <a:ea typeface="Calibri" pitchFamily="34" charset="-122"/>
+                <a:cs typeface="Calibri" pitchFamily="34" charset="-120"/>
+              </a:rPr>
+              <a:t> </a:t>
+            </a:r>
+            <a:r>
+              <a:rPr lang="en-US" sz="1000" dirty="0" err="1">
+                <a:solidFill>
+                  <a:srgbClr val="6B7280"/>
+                </a:solidFill>
+                <a:latin typeface="Calibri" pitchFamily="34" charset="0"/>
+                <a:ea typeface="Calibri" pitchFamily="34" charset="-122"/>
+                <a:cs typeface="Calibri" pitchFamily="34" charset="-120"/>
+              </a:rPr>
+              <a:t>modelo</a:t>
+            </a:r>
+            <a:r>
+              <a:rPr lang="en-US" sz="1000" dirty="0">
+                <a:solidFill>
+                  <a:srgbClr val="6B7280"/>
+                </a:solidFill>
+                <a:latin typeface="Calibri" pitchFamily="34" charset="0"/>
+                <a:ea typeface="Calibri" pitchFamily="34" charset="-122"/>
+                <a:cs typeface="Calibri" pitchFamily="34" charset="-120"/>
+              </a:rPr>
+              <a:t> </a:t>
+            </a:r>
+            <a:r>
+              <a:rPr lang="en-US" sz="1000" dirty="0" err="1">
+                <a:solidFill>
+                  <a:srgbClr val="6B7280"/>
+                </a:solidFill>
+                <a:latin typeface="Calibri" pitchFamily="34" charset="0"/>
+                <a:ea typeface="Calibri" pitchFamily="34" charset="-122"/>
+                <a:cs typeface="Calibri" pitchFamily="34" charset="-120"/>
+              </a:rPr>
+              <a:t>em</a:t>
+            </a:r>
+            <a:r>
+              <a:rPr lang="en-US" sz="1000" dirty="0">
+                <a:solidFill>
+                  <a:srgbClr val="6B7280"/>
+                </a:solidFill>
+                <a:latin typeface="Calibri" pitchFamily="34" charset="0"/>
+                <a:ea typeface="Calibri" pitchFamily="34" charset="-122"/>
+                <a:cs typeface="Calibri" pitchFamily="34" charset="-120"/>
+              </a:rPr>
+              <a:t> </a:t>
+            </a:r>
+            <a:r>
+              <a:rPr lang="en-US" sz="1000" dirty="0" err="1">
+                <a:solidFill>
+                  <a:srgbClr val="6B7280"/>
+                </a:solidFill>
+                <a:latin typeface="Calibri" pitchFamily="34" charset="0"/>
+                <a:ea typeface="Calibri" pitchFamily="34" charset="-122"/>
+                <a:cs typeface="Calibri" pitchFamily="34" charset="-120"/>
+              </a:rPr>
+              <a:t>nenhum</a:t>
+            </a:r>
+            <a:r>
+              <a:rPr lang="en-US" sz="1000" dirty="0">
+                <a:solidFill>
+                  <a:srgbClr val="6B7280"/>
+                </a:solidFill>
+                <a:latin typeface="Calibri" pitchFamily="34" charset="0"/>
+                <a:ea typeface="Calibri" pitchFamily="34" charset="-122"/>
+                <a:cs typeface="Calibri" pitchFamily="34" charset="-120"/>
+              </a:rPr>
+              <a:t> </a:t>
+            </a:r>
+            <a:r>
+              <a:rPr lang="en-US" sz="1000" dirty="0" err="1">
+                <a:solidFill>
+                  <a:srgbClr val="6B7280"/>
+                </a:solidFill>
+                <a:latin typeface="Calibri" pitchFamily="34" charset="0"/>
+                <a:ea typeface="Calibri" pitchFamily="34" charset="-122"/>
+                <a:cs typeface="Calibri" pitchFamily="34" charset="-120"/>
+              </a:rPr>
+              <a:t>caso</a:t>
+            </a:r>
+            <a:r>
+              <a:rPr lang="en-US" sz="1000" dirty="0">
+                <a:solidFill>
+                  <a:srgbClr val="6B7280"/>
+                </a:solidFill>
+                <a:latin typeface="Calibri" pitchFamily="34" charset="0"/>
+                <a:ea typeface="Calibri" pitchFamily="34" charset="-122"/>
+                <a:cs typeface="Calibri" pitchFamily="34" charset="-120"/>
+              </a:rPr>
+              <a:t> — parâmetros atuais geram performance inferior ao Discount em todos os segmentos</a:t>
             </a:r>
             <a:endParaRPr lang="en-US" sz="1200" dirty="0"/>
           </a:p>
@@ -6385,7 +7920,111 @@
                 <a:ea typeface="Calibri" pitchFamily="34" charset="-122"/>
                 <a:cs typeface="Calibri" pitchFamily="34" charset="-120"/>
               </a:rPr>
-              <a:t>2º maior driver de conversão (Feature Importance). Redistribuir budget de canal para social</a:t>
+              <a:t>2º maior driver de conversão (Feature Importance). </a:t>
+            </a:r>
+          </a:p>
+          <a:p>
+            <a:pPr marL="0" indent="0">
+              <a:buNone/>
+            </a:pPr>
+            <a:r>
+              <a:rPr lang="en-US" sz="1000" dirty="0">
+                <a:solidFill>
+                  <a:srgbClr val="6B7280"/>
+                </a:solidFill>
+                <a:latin typeface="Calibri" pitchFamily="34" charset="0"/>
+                <a:ea typeface="Calibri" pitchFamily="34" charset="-122"/>
+                <a:cs typeface="Calibri" pitchFamily="34" charset="-120"/>
+              </a:rPr>
+              <a:t>Testar </a:t>
+            </a:r>
+            <a:r>
+              <a:rPr lang="en-US" sz="1000" dirty="0" err="1">
+                <a:solidFill>
+                  <a:srgbClr val="6B7280"/>
+                </a:solidFill>
+                <a:latin typeface="Calibri" pitchFamily="34" charset="0"/>
+                <a:ea typeface="Calibri" pitchFamily="34" charset="-122"/>
+                <a:cs typeface="Calibri" pitchFamily="34" charset="-120"/>
+              </a:rPr>
+              <a:t>redistribuição</a:t>
+            </a:r>
+            <a:r>
+              <a:rPr lang="en-US" sz="1000" dirty="0">
+                <a:solidFill>
+                  <a:srgbClr val="6B7280"/>
+                </a:solidFill>
+                <a:latin typeface="Calibri" pitchFamily="34" charset="0"/>
+                <a:ea typeface="Calibri" pitchFamily="34" charset="-122"/>
+                <a:cs typeface="Calibri" pitchFamily="34" charset="-120"/>
+              </a:rPr>
+              <a:t> de budget de canal para </a:t>
+            </a:r>
+            <a:r>
+              <a:rPr lang="en-US" sz="1000" dirty="0" err="1">
+                <a:solidFill>
+                  <a:srgbClr val="6B7280"/>
+                </a:solidFill>
+                <a:latin typeface="Calibri" pitchFamily="34" charset="0"/>
+                <a:ea typeface="Calibri" pitchFamily="34" charset="-122"/>
+                <a:cs typeface="Calibri" pitchFamily="34" charset="-120"/>
+              </a:rPr>
+              <a:t>priorizar</a:t>
+            </a:r>
+            <a:r>
+              <a:rPr lang="en-US" sz="1000" dirty="0">
+                <a:solidFill>
+                  <a:srgbClr val="6B7280"/>
+                </a:solidFill>
+                <a:latin typeface="Calibri" pitchFamily="34" charset="0"/>
+                <a:ea typeface="Calibri" pitchFamily="34" charset="-122"/>
+                <a:cs typeface="Calibri" pitchFamily="34" charset="-120"/>
+              </a:rPr>
+              <a:t> o canal </a:t>
+            </a:r>
+            <a:r>
+              <a:rPr lang="en-US" sz="1000" dirty="0" err="1">
+                <a:solidFill>
+                  <a:srgbClr val="6B7280"/>
+                </a:solidFill>
+                <a:latin typeface="Calibri" pitchFamily="34" charset="0"/>
+                <a:ea typeface="Calibri" pitchFamily="34" charset="-122"/>
+                <a:cs typeface="Calibri" pitchFamily="34" charset="-120"/>
+              </a:rPr>
+              <a:t>descrito</a:t>
+            </a:r>
+            <a:r>
+              <a:rPr lang="en-US" sz="1000" dirty="0">
+                <a:solidFill>
+                  <a:srgbClr val="6B7280"/>
+                </a:solidFill>
+                <a:latin typeface="Calibri" pitchFamily="34" charset="0"/>
+                <a:ea typeface="Calibri" pitchFamily="34" charset="-122"/>
+                <a:cs typeface="Calibri" pitchFamily="34" charset="-120"/>
+              </a:rPr>
+              <a:t> </a:t>
+            </a:r>
+            <a:r>
+              <a:rPr lang="en-US" sz="1000" dirty="0" err="1">
+                <a:solidFill>
+                  <a:srgbClr val="6B7280"/>
+                </a:solidFill>
+                <a:latin typeface="Calibri" pitchFamily="34" charset="0"/>
+                <a:ea typeface="Calibri" pitchFamily="34" charset="-122"/>
+                <a:cs typeface="Calibri" pitchFamily="34" charset="-120"/>
+              </a:rPr>
+              <a:t>como</a:t>
+            </a:r>
+            <a:r>
+              <a:rPr lang="en-US" sz="1000" dirty="0">
+                <a:solidFill>
+                  <a:srgbClr val="6B7280"/>
+                </a:solidFill>
+                <a:latin typeface="Calibri" pitchFamily="34" charset="0"/>
+                <a:ea typeface="Calibri" pitchFamily="34" charset="-122"/>
+                <a:cs typeface="Calibri" pitchFamily="34" charset="-120"/>
+              </a:rPr>
+              <a:t> social</a:t>
             </a:r>
             <a:endParaRPr lang="en-US" sz="1200" dirty="0"/>
           </a:p>
@@ -6704,8 +8343,129 @@
                 <a:ea typeface="Calibri" pitchFamily="34" charset="-122"/>
                 <a:cs typeface="Calibri" pitchFamily="34" charset="-120"/>
               </a:rPr>
-              <a:t>• Experimento A/B controlado em produção para validar o ganho de +5.1 p.p.
-• Calibrar threshold de Sure Things via teste controlado</a:t>
+              <a:t>• </a:t>
+            </a:r>
+            <a:r>
+              <a:rPr lang="en-US" sz="950" dirty="0" err="1">
+                <a:solidFill>
+                  <a:srgbClr val="1A1A1A"/>
+                </a:solidFill>
+                <a:latin typeface="Calibri" pitchFamily="34" charset="0"/>
+                <a:ea typeface="Calibri" pitchFamily="34" charset="-122"/>
+                <a:cs typeface="Calibri" pitchFamily="34" charset="-120"/>
+              </a:rPr>
+              <a:t>Desenvolver</a:t>
+            </a:r>
+            <a:r>
+              <a:rPr lang="en-US" sz="950" dirty="0">
+                <a:solidFill>
+                  <a:srgbClr val="1A1A1A"/>
+                </a:solidFill>
+                <a:latin typeface="Calibri" pitchFamily="34" charset="0"/>
+                <a:ea typeface="Calibri" pitchFamily="34" charset="-122"/>
+                <a:cs typeface="Calibri" pitchFamily="34" charset="-120"/>
+              </a:rPr>
+              <a:t> </a:t>
+            </a:r>
+            <a:r>
+              <a:rPr lang="en-US" sz="950" dirty="0" err="1">
+                <a:solidFill>
+                  <a:srgbClr val="1A1A1A"/>
+                </a:solidFill>
+                <a:latin typeface="Calibri" pitchFamily="34" charset="0"/>
+                <a:ea typeface="Calibri" pitchFamily="34" charset="-122"/>
+                <a:cs typeface="Calibri" pitchFamily="34" charset="-120"/>
+              </a:rPr>
+              <a:t>modelo</a:t>
+            </a:r>
+            <a:r>
+              <a:rPr lang="en-US" sz="950" dirty="0">
+                <a:solidFill>
+                  <a:srgbClr val="1A1A1A"/>
+                </a:solidFill>
+                <a:latin typeface="Calibri" pitchFamily="34" charset="0"/>
+                <a:ea typeface="Calibri" pitchFamily="34" charset="-122"/>
+                <a:cs typeface="Calibri" pitchFamily="34" charset="-120"/>
+              </a:rPr>
+              <a:t> X-learner para </a:t>
+            </a:r>
+            <a:r>
+              <a:rPr lang="en-US" sz="950" dirty="0" err="1">
+                <a:solidFill>
+                  <a:srgbClr val="1A1A1A"/>
+                </a:solidFill>
+                <a:latin typeface="Calibri" pitchFamily="34" charset="0"/>
+                <a:ea typeface="Calibri" pitchFamily="34" charset="-122"/>
+                <a:cs typeface="Calibri" pitchFamily="34" charset="-120"/>
+              </a:rPr>
+              <a:t>validar</a:t>
+            </a:r>
+            <a:r>
+              <a:rPr lang="en-US" sz="950" dirty="0">
+                <a:solidFill>
+                  <a:srgbClr val="1A1A1A"/>
+                </a:solidFill>
+                <a:latin typeface="Calibri" pitchFamily="34" charset="0"/>
+                <a:ea typeface="Calibri" pitchFamily="34" charset="-122"/>
+                <a:cs typeface="Calibri" pitchFamily="34" charset="-120"/>
+              </a:rPr>
+              <a:t> o ganho de +5.1 p.p.
+• </a:t>
+            </a:r>
+            <a:r>
+              <a:rPr lang="en-US" sz="950" dirty="0" err="1">
+                <a:solidFill>
+                  <a:srgbClr val="1A1A1A"/>
+                </a:solidFill>
+                <a:latin typeface="Calibri" pitchFamily="34" charset="0"/>
+                <a:ea typeface="Calibri" pitchFamily="34" charset="-122"/>
+                <a:cs typeface="Calibri" pitchFamily="34" charset="-120"/>
+              </a:rPr>
+              <a:t>Modelar</a:t>
+            </a:r>
+            <a:r>
+              <a:rPr lang="en-US" sz="950" dirty="0">
+                <a:solidFill>
+                  <a:srgbClr val="1A1A1A"/>
+                </a:solidFill>
+                <a:latin typeface="Calibri" pitchFamily="34" charset="0"/>
+                <a:ea typeface="Calibri" pitchFamily="34" charset="-122"/>
+                <a:cs typeface="Calibri" pitchFamily="34" charset="-120"/>
+              </a:rPr>
+              <a:t> Sure Things com </a:t>
+            </a:r>
+            <a:r>
+              <a:rPr lang="en-US" sz="950" dirty="0" err="1">
+                <a:solidFill>
+                  <a:srgbClr val="1A1A1A"/>
+                </a:solidFill>
+                <a:latin typeface="Calibri" pitchFamily="34" charset="0"/>
+                <a:ea typeface="Calibri" pitchFamily="34" charset="-122"/>
+                <a:cs typeface="Calibri" pitchFamily="34" charset="-120"/>
+              </a:rPr>
+              <a:t>maior</a:t>
+            </a:r>
+            <a:r>
+              <a:rPr lang="en-US" sz="950" dirty="0">
+                <a:solidFill>
+                  <a:srgbClr val="1A1A1A"/>
+                </a:solidFill>
+                <a:latin typeface="Calibri" pitchFamily="34" charset="0"/>
+                <a:ea typeface="Calibri" pitchFamily="34" charset="-122"/>
+                <a:cs typeface="Calibri" pitchFamily="34" charset="-120"/>
+              </a:rPr>
+              <a:t> conjunto de </a:t>
+            </a:r>
+            <a:r>
+              <a:rPr lang="en-US" sz="950" dirty="0" err="1">
+                <a:solidFill>
+                  <a:srgbClr val="1A1A1A"/>
+                </a:solidFill>
+                <a:latin typeface="Calibri" pitchFamily="34" charset="0"/>
+                <a:ea typeface="Calibri" pitchFamily="34" charset="-122"/>
+                <a:cs typeface="Calibri" pitchFamily="34" charset="-120"/>
+              </a:rPr>
+              <a:t>variáveis</a:t>
             </a:r>
             <a:endParaRPr lang="en-US" sz="950" dirty="0"/>
           </a:p>
@@ -6748,7 +8508,7 @@
           <a:bodyPr/>
           <a:lstStyle/>
           <a:p>
-            <a:endParaRPr lang="pt-BR"/>
+            <a:endParaRPr lang="pt-BR" dirty="0"/>
           </a:p>
         </p:txBody>
       </p:sp>
@@ -6868,7 +8628,7 @@
           <a:bodyPr/>
           <a:lstStyle/>
           <a:p>
-            <a:endParaRPr lang="pt-BR"/>
+            <a:endParaRPr lang="pt-BR" dirty="0"/>
           </a:p>
         </p:txBody>
       </p:sp>
@@ -6944,8 +8704,52 @@
                 <a:ea typeface="Calibri" pitchFamily="34" charset="-122"/>
                 <a:cs typeface="Calibri" pitchFamily="34" charset="-120"/>
               </a:rPr>
-              <a:t>• Otimização de hiperparâmetros (Optuna) — ganho estimado de +2-3 p.p. em AUC
-• Redesenho de parâmetros do BOGO para testar nova configuração</a:t>
+              <a:t>• Otimização de </a:t>
+            </a:r>
+            <a:r>
+              <a:rPr lang="en-US" sz="950" dirty="0" err="1">
+                <a:solidFill>
+                  <a:srgbClr val="1A1A1A"/>
+                </a:solidFill>
+                <a:latin typeface="Calibri" pitchFamily="34" charset="0"/>
+                <a:ea typeface="Calibri" pitchFamily="34" charset="-122"/>
+                <a:cs typeface="Calibri" pitchFamily="34" charset="-120"/>
+              </a:rPr>
+              <a:t>hiperparâmetros</a:t>
+            </a:r>
+            <a:r>
+              <a:rPr lang="en-US" sz="950" dirty="0">
+                <a:solidFill>
+                  <a:srgbClr val="1A1A1A"/>
+                </a:solidFill>
+                <a:latin typeface="Calibri" pitchFamily="34" charset="0"/>
+                <a:ea typeface="Calibri" pitchFamily="34" charset="-122"/>
+                <a:cs typeface="Calibri" pitchFamily="34" charset="-120"/>
+              </a:rPr>
+              <a:t> — ganho estimado de +2-3 p.p. em AUC
+• Redesenho de parâmetros do BOGO e testes </a:t>
+            </a:r>
+            <a:r>
+              <a:rPr lang="en-US" sz="950" dirty="0" err="1">
+                <a:solidFill>
+                  <a:srgbClr val="1A1A1A"/>
+                </a:solidFill>
+                <a:latin typeface="Calibri" pitchFamily="34" charset="0"/>
+                <a:ea typeface="Calibri" pitchFamily="34" charset="-122"/>
+                <a:cs typeface="Calibri" pitchFamily="34" charset="-120"/>
+              </a:rPr>
+              <a:t>na</a:t>
+            </a:r>
+            <a:r>
+              <a:rPr lang="en-US" sz="950" dirty="0">
+                <a:solidFill>
+                  <a:srgbClr val="1A1A1A"/>
+                </a:solidFill>
+                <a:latin typeface="Calibri" pitchFamily="34" charset="0"/>
+                <a:ea typeface="Calibri" pitchFamily="34" charset="-122"/>
+                <a:cs typeface="Calibri" pitchFamily="34" charset="-120"/>
+              </a:rPr>
+              <a:t> nova configuração</a:t>
             </a:r>
             <a:endParaRPr lang="en-US" sz="950" dirty="0"/>
           </a:p>
@@ -7018,13 +8822,622 @@
                 <a:ea typeface="Calibri" pitchFamily="34" charset="-122"/>
                 <a:cs typeface="Calibri" pitchFamily="34" charset="-120"/>
               </a:rPr>
-              <a:t>💡  Estratégia validada em dados experimentais — pronta para teste em produção</a:t>
+              <a:t>💡  Estratégia validada em dados </a:t>
+            </a:r>
+            <a:r>
+              <a:rPr lang="en-US" sz="1200" b="1" dirty="0" err="1">
+                <a:solidFill>
+                  <a:srgbClr val="FFFFFF"/>
+                </a:solidFill>
+                <a:latin typeface="Calibri" pitchFamily="34" charset="0"/>
+                <a:ea typeface="Calibri" pitchFamily="34" charset="-122"/>
+                <a:cs typeface="Calibri" pitchFamily="34" charset="-120"/>
+              </a:rPr>
+              <a:t>experimentais</a:t>
             </a:r>
             <a:endParaRPr lang="en-US" sz="1200" dirty="0"/>
           </a:p>
         </p:txBody>
       </p:sp>
     </p:spTree>
+  </p:cSld>
+  <p:clrMapOvr>
+    <a:masterClrMapping/>
+  </p:clrMapOvr>
+</p:sld>
+</file>
+
+<file path=ppt/slides/slide6.xml><?xml version="1.0" encoding="utf-8"?>
+<p:sld xmlns:a="http://schemas.openxmlformats.org/drawingml/2006/main" xmlns:r="http://schemas.openxmlformats.org/officeDocument/2006/relationships" xmlns:p="http://schemas.openxmlformats.org/presentationml/2006/main">
+  <p:cSld>
+    <p:bg>
+      <p:bgPr>
+        <a:solidFill>
+          <a:srgbClr val="FFFFFF"/>
+        </a:solidFill>
+        <a:effectLst/>
+      </p:bgPr>
+    </p:bg>
+    <p:spTree>
+      <p:nvGrpSpPr>
+        <p:cNvPr id="1" name="">
+          <a:extLst>
+            <a:ext uri="{FF2B5EF4-FFF2-40B4-BE49-F238E27FC236}">
+              <a16:creationId xmlns:a16="http://schemas.microsoft.com/office/drawing/2014/main" id="{D8C1AC82-3384-4C4C-82B3-A18AB3FD97A5}"/>
+            </a:ext>
+          </a:extLst>
+        </p:cNvPr>
+        <p:cNvGrpSpPr/>
+        <p:nvPr/>
+      </p:nvGrpSpPr>
+      <p:grpSpPr>
+        <a:xfrm>
+          <a:off x="0" y="0"/>
+          <a:ext cx="0" cy="0"/>
+          <a:chOff x="0" y="0"/>
+          <a:chExt cx="0" cy="0"/>
+        </a:xfrm>
+      </p:grpSpPr>
+      <p:sp>
+        <p:nvSpPr>
+          <p:cNvPr id="32" name="Shape 23">
+            <a:extLst>
+              <a:ext uri="{FF2B5EF4-FFF2-40B4-BE49-F238E27FC236}">
+                <a16:creationId xmlns:a16="http://schemas.microsoft.com/office/drawing/2014/main" id="{43796242-EF2D-F92D-EB49-3BA23A697CB3}"/>
+              </a:ext>
+            </a:extLst>
+          </p:cNvPr>
+          <p:cNvSpPr/>
+          <p:nvPr/>
+        </p:nvSpPr>
+        <p:spPr>
+          <a:xfrm>
+            <a:off x="357510" y="4664526"/>
+            <a:ext cx="8229600" cy="411480"/>
+          </a:xfrm>
+          <a:prstGeom prst="roundRect">
+            <a:avLst>
+              <a:gd name="adj" fmla="val 13333"/>
+            </a:avLst>
+          </a:prstGeom>
+          <a:solidFill>
+            <a:srgbClr val="EA1D2C"/>
+          </a:solidFill>
+          <a:ln w="12700">
+            <a:solidFill>
+              <a:srgbClr val="EA1D2C"/>
+            </a:solidFill>
+            <a:prstDash val="solid"/>
+          </a:ln>
+        </p:spPr>
+        <p:txBody>
+          <a:bodyPr/>
+          <a:lstStyle/>
+          <a:p>
+            <a:endParaRPr lang="pt-BR"/>
+          </a:p>
+        </p:txBody>
+      </p:sp>
+      <p:sp>
+        <p:nvSpPr>
+          <p:cNvPr id="2" name="Shape 0">
+            <a:extLst>
+              <a:ext uri="{FF2B5EF4-FFF2-40B4-BE49-F238E27FC236}">
+                <a16:creationId xmlns:a16="http://schemas.microsoft.com/office/drawing/2014/main" id="{7C15F629-11B0-CF14-863C-BC3507D89594}"/>
+              </a:ext>
+            </a:extLst>
+          </p:cNvPr>
+          <p:cNvSpPr/>
+          <p:nvPr/>
+        </p:nvSpPr>
+        <p:spPr>
+          <a:xfrm>
+            <a:off x="0" y="0"/>
+            <a:ext cx="9144000" cy="914400"/>
+          </a:xfrm>
+          <a:prstGeom prst="rect">
+            <a:avLst/>
+          </a:prstGeom>
+          <a:solidFill>
+            <a:srgbClr val="EA1D2C"/>
+          </a:solidFill>
+          <a:ln w="12700">
+            <a:solidFill>
+              <a:srgbClr val="EA1D2C"/>
+            </a:solidFill>
+            <a:prstDash val="solid"/>
+          </a:ln>
+        </p:spPr>
+        <p:txBody>
+          <a:bodyPr/>
+          <a:lstStyle/>
+          <a:p>
+            <a:endParaRPr lang="pt-BR"/>
+          </a:p>
+        </p:txBody>
+      </p:sp>
+      <p:sp>
+        <p:nvSpPr>
+          <p:cNvPr id="3" name="Text 1">
+            <a:extLst>
+              <a:ext uri="{FF2B5EF4-FFF2-40B4-BE49-F238E27FC236}">
+                <a16:creationId xmlns:a16="http://schemas.microsoft.com/office/drawing/2014/main" id="{36C7E697-EAC8-D19D-9947-5661D8A7D72E}"/>
+              </a:ext>
+            </a:extLst>
+          </p:cNvPr>
+          <p:cNvSpPr/>
+          <p:nvPr/>
+        </p:nvSpPr>
+        <p:spPr>
+          <a:xfrm>
+            <a:off x="457200" y="137160"/>
+            <a:ext cx="8229600" cy="594360"/>
+          </a:xfrm>
+          <a:prstGeom prst="rect">
+            <a:avLst/>
+          </a:prstGeom>
+          <a:noFill/>
+          <a:ln/>
+        </p:spPr>
+        <p:txBody>
+          <a:bodyPr wrap="square" lIns="0" tIns="0" rIns="0" bIns="0" rtlCol="0" anchor="ctr"/>
+          <a:lstStyle/>
+          <a:p>
+            <a:pPr marL="0" indent="0">
+              <a:buNone/>
+            </a:pPr>
+            <a:r>
+              <a:rPr lang="en-US" sz="2600" b="1" dirty="0">
+                <a:solidFill>
+                  <a:srgbClr val="FFFFFF"/>
+                </a:solidFill>
+                <a:latin typeface="Cambria" pitchFamily="34" charset="0"/>
+                <a:ea typeface="Cambria" pitchFamily="34" charset="-122"/>
+                <a:cs typeface="Cambria" pitchFamily="34" charset="-120"/>
+              </a:rPr>
+              <a:t>O Modelo S-Learner </a:t>
+            </a:r>
+            <a:endParaRPr lang="en-US" sz="2600" dirty="0"/>
+          </a:p>
+        </p:txBody>
+      </p:sp>
+      <p:sp>
+        <p:nvSpPr>
+          <p:cNvPr id="26" name="CaixaDeTexto 25">
+            <a:extLst>
+              <a:ext uri="{FF2B5EF4-FFF2-40B4-BE49-F238E27FC236}">
+                <a16:creationId xmlns:a16="http://schemas.microsoft.com/office/drawing/2014/main" id="{12DD0C76-7C84-2279-F58F-9FF85B139B2F}"/>
+              </a:ext>
+            </a:extLst>
+          </p:cNvPr>
+          <p:cNvSpPr txBox="1"/>
+          <p:nvPr/>
+        </p:nvSpPr>
+        <p:spPr>
+          <a:xfrm>
+            <a:off x="5238894" y="1168135"/>
+            <a:ext cx="3905106" cy="2185214"/>
+          </a:xfrm>
+          <a:prstGeom prst="rect">
+            <a:avLst/>
+          </a:prstGeom>
+          <a:noFill/>
+        </p:spPr>
+        <p:txBody>
+          <a:bodyPr wrap="square">
+            <a:spAutoFit/>
+          </a:bodyPr>
+          <a:lstStyle/>
+          <a:p>
+            <a:pPr marL="285750" indent="-285750">
+              <a:buFont typeface="Arial" panose="020B0604020202020204" pitchFamily="34" charset="0"/>
+              <a:buChar char="•"/>
+            </a:pPr>
+            <a:r>
+              <a:rPr lang="pt-BR" sz="1400" b="1" dirty="0"/>
+              <a:t>X</a:t>
+            </a:r>
+            <a:r>
+              <a:rPr lang="pt-BR" sz="1400" dirty="0"/>
+              <a:t> — as </a:t>
+            </a:r>
+            <a:r>
+              <a:rPr lang="pt-BR" sz="1400" b="1" dirty="0"/>
+              <a:t>covariáveis</a:t>
+            </a:r>
+            <a:r>
+              <a:rPr lang="pt-BR" sz="1400" dirty="0"/>
+              <a:t> (features do cliente)</a:t>
+            </a:r>
+          </a:p>
+          <a:p>
+            <a:pPr marL="285750" indent="-285750">
+              <a:buFont typeface="Arial" panose="020B0604020202020204" pitchFamily="34" charset="0"/>
+              <a:buChar char="•"/>
+            </a:pPr>
+            <a:r>
+              <a:rPr lang="pt-BR" sz="1400" b="1" dirty="0"/>
+              <a:t>W</a:t>
+            </a:r>
+            <a:r>
+              <a:rPr lang="pt-BR" sz="1400" dirty="0"/>
+              <a:t> — o </a:t>
+            </a:r>
+            <a:r>
+              <a:rPr lang="pt-BR" sz="1400" b="1" dirty="0"/>
+              <a:t>indicador/tipo de tratamento</a:t>
+            </a:r>
+            <a:r>
+              <a:rPr lang="pt-BR" sz="1400" dirty="0"/>
+              <a:t>: qual oferta o cliente recebeu e variáveis associadas</a:t>
+            </a:r>
+          </a:p>
+          <a:p>
+            <a:pPr marL="742950" lvl="1" indent="-285750">
+              <a:buFont typeface="Arial" panose="020B0604020202020204" pitchFamily="34" charset="0"/>
+              <a:buChar char="•"/>
+            </a:pPr>
+            <a:r>
+              <a:rPr lang="pt-BR" sz="1100" dirty="0"/>
+              <a:t>Nos </a:t>
+            </a:r>
+            <a:r>
+              <a:rPr lang="pt-BR" sz="1100" dirty="0" err="1"/>
+              <a:t>papers</a:t>
+            </a:r>
+            <a:r>
+              <a:rPr lang="pt-BR" sz="1100" dirty="0"/>
+              <a:t> mais teóricos (X-</a:t>
+            </a:r>
+            <a:r>
+              <a:rPr lang="pt-BR" sz="1100" dirty="0" err="1"/>
+              <a:t>learner</a:t>
+            </a:r>
+            <a:r>
+              <a:rPr lang="pt-BR" sz="1100" dirty="0"/>
+              <a:t>), </a:t>
+            </a:r>
+            <a:r>
+              <a:rPr lang="pt-BR" sz="1100" b="1" dirty="0"/>
+              <a:t>W</a:t>
+            </a:r>
+            <a:r>
+              <a:rPr lang="pt-BR" sz="1100" dirty="0"/>
+              <a:t> costuma ser binário (0=controle, 1=tratado); no case é categórico com 3 níveis, mas o papel é o mesmo — é a variável que indica </a:t>
+            </a:r>
+            <a:r>
+              <a:rPr lang="pt-BR" sz="1100" b="1" dirty="0"/>
+              <a:t>qual tratamento</a:t>
+            </a:r>
+            <a:r>
+              <a:rPr lang="pt-BR" sz="1100" dirty="0"/>
+              <a:t> aquela unidade recebeu. </a:t>
+            </a:r>
+          </a:p>
+          <a:p>
+            <a:pPr marL="285750" indent="-285750">
+              <a:buFont typeface="Arial" panose="020B0604020202020204" pitchFamily="34" charset="0"/>
+              <a:buChar char="•"/>
+            </a:pPr>
+            <a:r>
+              <a:rPr lang="pt-BR" sz="1400" b="1" dirty="0"/>
+              <a:t>Y</a:t>
+            </a:r>
+            <a:r>
+              <a:rPr lang="pt-BR" sz="1400" dirty="0"/>
+              <a:t> — o </a:t>
+            </a:r>
+            <a:r>
+              <a:rPr lang="pt-BR" sz="1400" b="1" dirty="0"/>
+              <a:t>desfecho observado</a:t>
+            </a:r>
+            <a:r>
+              <a:rPr lang="pt-BR" sz="1400" dirty="0"/>
+              <a:t>: se o cliente converteu ou não. </a:t>
+            </a:r>
+          </a:p>
+          <a:p>
+            <a:pPr marL="742950" lvl="1" indent="-285750">
+              <a:buFont typeface="Arial" panose="020B0604020202020204" pitchFamily="34" charset="0"/>
+              <a:buChar char="•"/>
+            </a:pPr>
+            <a:r>
+              <a:rPr lang="pt-BR" sz="1100" dirty="0" err="1"/>
+              <a:t>target_engaged_conversion</a:t>
+            </a:r>
+            <a:endParaRPr lang="pt-BR" sz="1100" dirty="0"/>
+          </a:p>
+        </p:txBody>
+      </p:sp>
+      <p:pic>
+        <p:nvPicPr>
+          <p:cNvPr id="31" name="Imagem 30">
+            <a:extLst>
+              <a:ext uri="{FF2B5EF4-FFF2-40B4-BE49-F238E27FC236}">
+                <a16:creationId xmlns:a16="http://schemas.microsoft.com/office/drawing/2014/main" id="{B458D7F8-DBB0-2E7B-22CC-C0B3EB70B881}"/>
+              </a:ext>
+            </a:extLst>
+          </p:cNvPr>
+          <p:cNvPicPr>
+            <a:picLocks noChangeAspect="1"/>
+          </p:cNvPicPr>
+          <p:nvPr/>
+        </p:nvPicPr>
+        <p:blipFill>
+          <a:blip r:embed="rId3"/>
+          <a:stretch>
+            <a:fillRect/>
+          </a:stretch>
+        </p:blipFill>
+        <p:spPr>
+          <a:xfrm>
+            <a:off x="103619" y="1113781"/>
+            <a:ext cx="5195218" cy="3526324"/>
+          </a:xfrm>
+          <a:prstGeom prst="rect">
+            <a:avLst/>
+          </a:prstGeom>
+        </p:spPr>
+      </p:pic>
+      <p:sp>
+        <p:nvSpPr>
+          <p:cNvPr id="27" name="CaixaDeTexto 26">
+            <a:extLst>
+              <a:ext uri="{FF2B5EF4-FFF2-40B4-BE49-F238E27FC236}">
+                <a16:creationId xmlns:a16="http://schemas.microsoft.com/office/drawing/2014/main" id="{BCD4DA31-AB7C-CDE1-B60E-05CA08186176}"/>
+              </a:ext>
+            </a:extLst>
+          </p:cNvPr>
+          <p:cNvSpPr txBox="1"/>
+          <p:nvPr/>
+        </p:nvSpPr>
+        <p:spPr>
+          <a:xfrm>
+            <a:off x="708144" y="4716378"/>
+            <a:ext cx="8332728" cy="307777"/>
+          </a:xfrm>
+          <a:prstGeom prst="rect">
+            <a:avLst/>
+          </a:prstGeom>
+          <a:noFill/>
+        </p:spPr>
+        <p:txBody>
+          <a:bodyPr wrap="square" rtlCol="0">
+            <a:spAutoFit/>
+          </a:bodyPr>
+          <a:lstStyle/>
+          <a:p>
+            <a:r>
+              <a:rPr lang="pt-BR" sz="1400" dirty="0">
+                <a:solidFill>
+                  <a:srgbClr val="FFFFFF"/>
+                </a:solidFill>
+              </a:rPr>
+              <a:t>Next steps: implementação do algoritmo X-</a:t>
+            </a:r>
+            <a:r>
+              <a:rPr lang="pt-BR" sz="1400" dirty="0" err="1">
+                <a:solidFill>
+                  <a:srgbClr val="FFFFFF"/>
+                </a:solidFill>
+              </a:rPr>
+              <a:t>learner</a:t>
+            </a:r>
+            <a:r>
+              <a:rPr lang="pt-BR" sz="1400" dirty="0">
+                <a:solidFill>
+                  <a:srgbClr val="FFFFFF"/>
+                </a:solidFill>
+              </a:rPr>
+              <a:t>, mais robusto, considerando análise contrafactual.</a:t>
+            </a:r>
+          </a:p>
+        </p:txBody>
+      </p:sp>
+    </p:spTree>
+    <p:extLst>
+      <p:ext uri="{BB962C8B-B14F-4D97-AF65-F5344CB8AC3E}">
+        <p14:creationId xmlns:p14="http://schemas.microsoft.com/office/powerpoint/2010/main" val="3401654431"/>
+      </p:ext>
+    </p:extLst>
+  </p:cSld>
+  <p:clrMapOvr>
+    <a:masterClrMapping/>
+  </p:clrMapOvr>
+</p:sld>
+</file>
+
+<file path=ppt/slides/slide7.xml><?xml version="1.0" encoding="utf-8"?>
+<p:sld xmlns:a="http://schemas.openxmlformats.org/drawingml/2006/main" xmlns:r="http://schemas.openxmlformats.org/officeDocument/2006/relationships" xmlns:p="http://schemas.openxmlformats.org/presentationml/2006/main">
+  <p:cSld>
+    <p:bg>
+      <p:bgPr>
+        <a:solidFill>
+          <a:srgbClr val="FFFFFF"/>
+        </a:solidFill>
+        <a:effectLst/>
+      </p:bgPr>
+    </p:bg>
+    <p:spTree>
+      <p:nvGrpSpPr>
+        <p:cNvPr id="1" name="">
+          <a:extLst>
+            <a:ext uri="{FF2B5EF4-FFF2-40B4-BE49-F238E27FC236}">
+              <a16:creationId xmlns:a16="http://schemas.microsoft.com/office/drawing/2014/main" id="{BD6D9AA2-E32E-DCDB-3436-85005436CB33}"/>
+            </a:ext>
+          </a:extLst>
+        </p:cNvPr>
+        <p:cNvGrpSpPr/>
+        <p:nvPr/>
+      </p:nvGrpSpPr>
+      <p:grpSpPr>
+        <a:xfrm>
+          <a:off x="0" y="0"/>
+          <a:ext cx="0" cy="0"/>
+          <a:chOff x="0" y="0"/>
+          <a:chExt cx="0" cy="0"/>
+        </a:xfrm>
+      </p:grpSpPr>
+      <p:sp>
+        <p:nvSpPr>
+          <p:cNvPr id="2" name="Shape 0">
+            <a:extLst>
+              <a:ext uri="{FF2B5EF4-FFF2-40B4-BE49-F238E27FC236}">
+                <a16:creationId xmlns:a16="http://schemas.microsoft.com/office/drawing/2014/main" id="{39DD066E-4F87-439B-4810-52503A95C06C}"/>
+              </a:ext>
+            </a:extLst>
+          </p:cNvPr>
+          <p:cNvSpPr/>
+          <p:nvPr/>
+        </p:nvSpPr>
+        <p:spPr>
+          <a:xfrm>
+            <a:off x="0" y="0"/>
+            <a:ext cx="9144000" cy="914400"/>
+          </a:xfrm>
+          <a:prstGeom prst="rect">
+            <a:avLst/>
+          </a:prstGeom>
+          <a:solidFill>
+            <a:srgbClr val="EA1D2C"/>
+          </a:solidFill>
+          <a:ln w="12700">
+            <a:solidFill>
+              <a:srgbClr val="EA1D2C"/>
+            </a:solidFill>
+            <a:prstDash val="solid"/>
+          </a:ln>
+        </p:spPr>
+        <p:txBody>
+          <a:bodyPr/>
+          <a:lstStyle/>
+          <a:p>
+            <a:endParaRPr lang="pt-BR"/>
+          </a:p>
+        </p:txBody>
+      </p:sp>
+      <p:sp>
+        <p:nvSpPr>
+          <p:cNvPr id="3" name="Text 1">
+            <a:extLst>
+              <a:ext uri="{FF2B5EF4-FFF2-40B4-BE49-F238E27FC236}">
+                <a16:creationId xmlns:a16="http://schemas.microsoft.com/office/drawing/2014/main" id="{D569387B-9F53-6830-85ED-349710E6A321}"/>
+              </a:ext>
+            </a:extLst>
+          </p:cNvPr>
+          <p:cNvSpPr/>
+          <p:nvPr/>
+        </p:nvSpPr>
+        <p:spPr>
+          <a:xfrm>
+            <a:off x="457200" y="137160"/>
+            <a:ext cx="8229600" cy="594360"/>
+          </a:xfrm>
+          <a:prstGeom prst="rect">
+            <a:avLst/>
+          </a:prstGeom>
+          <a:noFill/>
+          <a:ln/>
+        </p:spPr>
+        <p:txBody>
+          <a:bodyPr wrap="square" lIns="0" tIns="0" rIns="0" bIns="0" rtlCol="0" anchor="ctr"/>
+          <a:lstStyle/>
+          <a:p>
+            <a:pPr marL="0" indent="0">
+              <a:buNone/>
+            </a:pPr>
+            <a:r>
+              <a:rPr lang="en-US" sz="2600" b="1" dirty="0">
+                <a:solidFill>
+                  <a:srgbClr val="FFFFFF"/>
+                </a:solidFill>
+                <a:latin typeface="Cambria" pitchFamily="34" charset="0"/>
+                <a:ea typeface="Cambria" pitchFamily="34" charset="-122"/>
+                <a:cs typeface="Cambria" pitchFamily="34" charset="-120"/>
+              </a:rPr>
+              <a:t>Analise das </a:t>
+            </a:r>
+            <a:r>
+              <a:rPr lang="en-US" sz="2600" b="1" dirty="0" err="1">
+                <a:solidFill>
+                  <a:srgbClr val="FFFFFF"/>
+                </a:solidFill>
+                <a:latin typeface="Cambria" pitchFamily="34" charset="0"/>
+                <a:ea typeface="Cambria" pitchFamily="34" charset="-122"/>
+                <a:cs typeface="Cambria" pitchFamily="34" charset="-120"/>
+              </a:rPr>
+              <a:t>regressoras</a:t>
+            </a:r>
+            <a:endParaRPr lang="en-US" sz="2600" dirty="0"/>
+          </a:p>
+        </p:txBody>
+      </p:sp>
+      <p:pic>
+        <p:nvPicPr>
+          <p:cNvPr id="4" name="Imagem 3">
+            <a:extLst>
+              <a:ext uri="{FF2B5EF4-FFF2-40B4-BE49-F238E27FC236}">
+                <a16:creationId xmlns:a16="http://schemas.microsoft.com/office/drawing/2014/main" id="{57B8D5D3-D1D3-B699-040A-D0882F698139}"/>
+              </a:ext>
+            </a:extLst>
+          </p:cNvPr>
+          <p:cNvPicPr>
+            <a:picLocks noChangeAspect="1"/>
+          </p:cNvPicPr>
+          <p:nvPr/>
+        </p:nvPicPr>
+        <p:blipFill>
+          <a:blip r:embed="rId3"/>
+          <a:stretch>
+            <a:fillRect/>
+          </a:stretch>
+        </p:blipFill>
+        <p:spPr>
+          <a:xfrm>
+            <a:off x="21181" y="1210033"/>
+            <a:ext cx="4849945" cy="3452205"/>
+          </a:xfrm>
+          <a:prstGeom prst="rect">
+            <a:avLst/>
+          </a:prstGeom>
+        </p:spPr>
+      </p:pic>
+      <p:pic>
+        <p:nvPicPr>
+          <p:cNvPr id="5" name="Imagem 4">
+            <a:extLst>
+              <a:ext uri="{FF2B5EF4-FFF2-40B4-BE49-F238E27FC236}">
+                <a16:creationId xmlns:a16="http://schemas.microsoft.com/office/drawing/2014/main" id="{F35195A6-19B2-D128-99B9-BA213A3F01FE}"/>
+              </a:ext>
+            </a:extLst>
+          </p:cNvPr>
+          <p:cNvPicPr>
+            <a:picLocks noChangeAspect="1"/>
+          </p:cNvPicPr>
+          <p:nvPr/>
+        </p:nvPicPr>
+        <p:blipFill>
+          <a:blip r:embed="rId4"/>
+          <a:stretch>
+            <a:fillRect/>
+          </a:stretch>
+        </p:blipFill>
+        <p:spPr>
+          <a:xfrm>
+            <a:off x="4871126" y="1698171"/>
+            <a:ext cx="4272874" cy="2469050"/>
+          </a:xfrm>
+          <a:prstGeom prst="rect">
+            <a:avLst/>
+          </a:prstGeom>
+        </p:spPr>
+      </p:pic>
+    </p:spTree>
+    <p:extLst>
+      <p:ext uri="{BB962C8B-B14F-4D97-AF65-F5344CB8AC3E}">
+        <p14:creationId xmlns:p14="http://schemas.microsoft.com/office/powerpoint/2010/main" val="4222430810"/>
+      </p:ext>
+    </p:extLst>
   </p:cSld>
   <p:clrMapOvr>
     <a:masterClrMapping/>

</xml_diff>